<commit_message>
docs: ✏️ update diagrams - modified PNG and PPTX files
</commit_message>
<xml_diff>
--- a/docs/diagrams.pptx
+++ b/docs/diagrams.pptx
@@ -107,7 +107,18 @@
   </p:defaultTextStyle>
   <p:extLst>
     <p:ext uri="{EFAFB233-063F-42B5-8137-9DF3F51BA10A}">
-      <p15:sldGuideLst xmlns:p15="http://schemas.microsoft.com/office/powerpoint/2012/main" xmlns=""/>
+      <p15:sldGuideLst xmlns:p15="http://schemas.microsoft.com/office/powerpoint/2012/main">
+        <p15:guide id="1" orient="horz" pos="2160">
+          <p15:clr>
+            <a:srgbClr val="A4A3A4"/>
+          </p15:clr>
+        </p15:guide>
+        <p15:guide id="2" pos="3840">
+          <p15:clr>
+            <a:srgbClr val="A4A3A4"/>
+          </p15:clr>
+        </p15:guide>
+      </p15:sldGuideLst>
     </p:ext>
   </p:extLst>
 </p:presentation>
@@ -245,7 +256,7 @@
             <a:fld id="{388BEFF6-CA1E-4F2C-AB17-C8AC986E5615}" type="datetimeFigureOut">
               <a:rPr lang="en-US" smtClean="0"/>
               <a:pPr/>
-              <a:t>8/12/2024</a:t>
+              <a:t>4/10/2026</a:t>
             </a:fld>
             <a:endParaRPr lang="en-US" dirty="0"/>
           </a:p>
@@ -288,7 +299,7 @@
             <a:fld id="{B2B78684-98AC-4705-8032-58D98476EAE5}" type="slidenum">
               <a:rPr lang="en-US" smtClean="0"/>
               <a:pPr/>
-              <a:t>‹N°›</a:t>
+              <a:t>‹#›</a:t>
             </a:fld>
             <a:endParaRPr lang="en-US" dirty="0"/>
           </a:p>
@@ -297,7 +308,7 @@
     </p:spTree>
     <p:extLst>
       <p:ext uri="{BB962C8B-B14F-4D97-AF65-F5344CB8AC3E}">
-        <p14:creationId xmlns:p14="http://schemas.microsoft.com/office/powerpoint/2010/main" xmlns="" val="2436347131"/>
+        <p14:creationId xmlns:p14="http://schemas.microsoft.com/office/powerpoint/2010/main" val="2436347131"/>
       </p:ext>
     </p:extLst>
   </p:cSld>
@@ -417,7 +428,7 @@
             <a:fld id="{388BEFF6-CA1E-4F2C-AB17-C8AC986E5615}" type="datetimeFigureOut">
               <a:rPr lang="en-US" smtClean="0"/>
               <a:pPr/>
-              <a:t>8/12/2024</a:t>
+              <a:t>4/10/2026</a:t>
             </a:fld>
             <a:endParaRPr lang="en-US" dirty="0"/>
           </a:p>
@@ -460,7 +471,7 @@
             <a:fld id="{B2B78684-98AC-4705-8032-58D98476EAE5}" type="slidenum">
               <a:rPr lang="en-US" smtClean="0"/>
               <a:pPr/>
-              <a:t>‹N°›</a:t>
+              <a:t>‹#›</a:t>
             </a:fld>
             <a:endParaRPr lang="en-US" dirty="0"/>
           </a:p>
@@ -469,7 +480,7 @@
     </p:spTree>
     <p:extLst>
       <p:ext uri="{BB962C8B-B14F-4D97-AF65-F5344CB8AC3E}">
-        <p14:creationId xmlns:p14="http://schemas.microsoft.com/office/powerpoint/2010/main" xmlns="" val="488834116"/>
+        <p14:creationId xmlns:p14="http://schemas.microsoft.com/office/powerpoint/2010/main" val="488834116"/>
       </p:ext>
     </p:extLst>
   </p:cSld>
@@ -599,7 +610,7 @@
             <a:fld id="{388BEFF6-CA1E-4F2C-AB17-C8AC986E5615}" type="datetimeFigureOut">
               <a:rPr lang="en-US" smtClean="0"/>
               <a:pPr/>
-              <a:t>8/12/2024</a:t>
+              <a:t>4/10/2026</a:t>
             </a:fld>
             <a:endParaRPr lang="en-US" dirty="0"/>
           </a:p>
@@ -642,7 +653,7 @@
             <a:fld id="{B2B78684-98AC-4705-8032-58D98476EAE5}" type="slidenum">
               <a:rPr lang="en-US" smtClean="0"/>
               <a:pPr/>
-              <a:t>‹N°›</a:t>
+              <a:t>‹#›</a:t>
             </a:fld>
             <a:endParaRPr lang="en-US" dirty="0"/>
           </a:p>
@@ -651,7 +662,7 @@
     </p:spTree>
     <p:extLst>
       <p:ext uri="{BB962C8B-B14F-4D97-AF65-F5344CB8AC3E}">
-        <p14:creationId xmlns:p14="http://schemas.microsoft.com/office/powerpoint/2010/main" xmlns="" val="3817113929"/>
+        <p14:creationId xmlns:p14="http://schemas.microsoft.com/office/powerpoint/2010/main" val="3817113929"/>
       </p:ext>
     </p:extLst>
   </p:cSld>
@@ -771,7 +782,7 @@
             <a:fld id="{388BEFF6-CA1E-4F2C-AB17-C8AC986E5615}" type="datetimeFigureOut">
               <a:rPr lang="en-US" smtClean="0"/>
               <a:pPr/>
-              <a:t>8/12/2024</a:t>
+              <a:t>4/10/2026</a:t>
             </a:fld>
             <a:endParaRPr lang="en-US" dirty="0"/>
           </a:p>
@@ -814,7 +825,7 @@
             <a:fld id="{B2B78684-98AC-4705-8032-58D98476EAE5}" type="slidenum">
               <a:rPr lang="en-US" smtClean="0"/>
               <a:pPr/>
-              <a:t>‹N°›</a:t>
+              <a:t>‹#›</a:t>
             </a:fld>
             <a:endParaRPr lang="en-US" dirty="0"/>
           </a:p>
@@ -823,7 +834,7 @@
     </p:spTree>
     <p:extLst>
       <p:ext uri="{BB962C8B-B14F-4D97-AF65-F5344CB8AC3E}">
-        <p14:creationId xmlns:p14="http://schemas.microsoft.com/office/powerpoint/2010/main" xmlns="" val="2511372462"/>
+        <p14:creationId xmlns:p14="http://schemas.microsoft.com/office/powerpoint/2010/main" val="2511372462"/>
       </p:ext>
     </p:extLst>
   </p:cSld>
@@ -1019,7 +1030,7 @@
             <a:fld id="{388BEFF6-CA1E-4F2C-AB17-C8AC986E5615}" type="datetimeFigureOut">
               <a:rPr lang="en-US" smtClean="0"/>
               <a:pPr/>
-              <a:t>8/12/2024</a:t>
+              <a:t>4/10/2026</a:t>
             </a:fld>
             <a:endParaRPr lang="en-US" dirty="0"/>
           </a:p>
@@ -1062,7 +1073,7 @@
             <a:fld id="{B2B78684-98AC-4705-8032-58D98476EAE5}" type="slidenum">
               <a:rPr lang="en-US" smtClean="0"/>
               <a:pPr/>
-              <a:t>‹N°›</a:t>
+              <a:t>‹#›</a:t>
             </a:fld>
             <a:endParaRPr lang="en-US" dirty="0"/>
           </a:p>
@@ -1071,7 +1082,7 @@
     </p:spTree>
     <p:extLst>
       <p:ext uri="{BB962C8B-B14F-4D97-AF65-F5344CB8AC3E}">
-        <p14:creationId xmlns:p14="http://schemas.microsoft.com/office/powerpoint/2010/main" xmlns="" val="890383841"/>
+        <p14:creationId xmlns:p14="http://schemas.microsoft.com/office/powerpoint/2010/main" val="890383841"/>
       </p:ext>
     </p:extLst>
   </p:cSld>
@@ -1253,7 +1264,7 @@
             <a:fld id="{388BEFF6-CA1E-4F2C-AB17-C8AC986E5615}" type="datetimeFigureOut">
               <a:rPr lang="en-US" smtClean="0"/>
               <a:pPr/>
-              <a:t>8/12/2024</a:t>
+              <a:t>4/10/2026</a:t>
             </a:fld>
             <a:endParaRPr lang="en-US" dirty="0"/>
           </a:p>
@@ -1296,7 +1307,7 @@
             <a:fld id="{B2B78684-98AC-4705-8032-58D98476EAE5}" type="slidenum">
               <a:rPr lang="en-US" smtClean="0"/>
               <a:pPr/>
-              <a:t>‹N°›</a:t>
+              <a:t>‹#›</a:t>
             </a:fld>
             <a:endParaRPr lang="en-US" dirty="0"/>
           </a:p>
@@ -1305,7 +1316,7 @@
     </p:spTree>
     <p:extLst>
       <p:ext uri="{BB962C8B-B14F-4D97-AF65-F5344CB8AC3E}">
-        <p14:creationId xmlns:p14="http://schemas.microsoft.com/office/powerpoint/2010/main" xmlns="" val="1347279164"/>
+        <p14:creationId xmlns:p14="http://schemas.microsoft.com/office/powerpoint/2010/main" val="1347279164"/>
       </p:ext>
     </p:extLst>
   </p:cSld>
@@ -1622,7 +1633,7 @@
             <a:fld id="{388BEFF6-CA1E-4F2C-AB17-C8AC986E5615}" type="datetimeFigureOut">
               <a:rPr lang="en-US" smtClean="0"/>
               <a:pPr/>
-              <a:t>8/12/2024</a:t>
+              <a:t>4/10/2026</a:t>
             </a:fld>
             <a:endParaRPr lang="en-US" dirty="0"/>
           </a:p>
@@ -1665,7 +1676,7 @@
             <a:fld id="{B2B78684-98AC-4705-8032-58D98476EAE5}" type="slidenum">
               <a:rPr lang="en-US" smtClean="0"/>
               <a:pPr/>
-              <a:t>‹N°›</a:t>
+              <a:t>‹#›</a:t>
             </a:fld>
             <a:endParaRPr lang="en-US" dirty="0"/>
           </a:p>
@@ -1674,7 +1685,7 @@
     </p:spTree>
     <p:extLst>
       <p:ext uri="{BB962C8B-B14F-4D97-AF65-F5344CB8AC3E}">
-        <p14:creationId xmlns:p14="http://schemas.microsoft.com/office/powerpoint/2010/main" xmlns="" val="2734694137"/>
+        <p14:creationId xmlns:p14="http://schemas.microsoft.com/office/powerpoint/2010/main" val="2734694137"/>
       </p:ext>
     </p:extLst>
   </p:cSld>
@@ -1742,7 +1753,7 @@
             <a:fld id="{388BEFF6-CA1E-4F2C-AB17-C8AC986E5615}" type="datetimeFigureOut">
               <a:rPr lang="en-US" smtClean="0"/>
               <a:pPr/>
-              <a:t>8/12/2024</a:t>
+              <a:t>4/10/2026</a:t>
             </a:fld>
             <a:endParaRPr lang="en-US" dirty="0"/>
           </a:p>
@@ -1785,7 +1796,7 @@
             <a:fld id="{B2B78684-98AC-4705-8032-58D98476EAE5}" type="slidenum">
               <a:rPr lang="en-US" smtClean="0"/>
               <a:pPr/>
-              <a:t>‹N°›</a:t>
+              <a:t>‹#›</a:t>
             </a:fld>
             <a:endParaRPr lang="en-US" dirty="0"/>
           </a:p>
@@ -1794,7 +1805,7 @@
     </p:spTree>
     <p:extLst>
       <p:ext uri="{BB962C8B-B14F-4D97-AF65-F5344CB8AC3E}">
-        <p14:creationId xmlns:p14="http://schemas.microsoft.com/office/powerpoint/2010/main" xmlns="" val="2753302791"/>
+        <p14:creationId xmlns:p14="http://schemas.microsoft.com/office/powerpoint/2010/main" val="2753302791"/>
       </p:ext>
     </p:extLst>
   </p:cSld>
@@ -1839,7 +1850,7 @@
             <a:fld id="{388BEFF6-CA1E-4F2C-AB17-C8AC986E5615}" type="datetimeFigureOut">
               <a:rPr lang="en-US" smtClean="0"/>
               <a:pPr/>
-              <a:t>8/12/2024</a:t>
+              <a:t>4/10/2026</a:t>
             </a:fld>
             <a:endParaRPr lang="en-US" dirty="0"/>
           </a:p>
@@ -1882,7 +1893,7 @@
             <a:fld id="{B2B78684-98AC-4705-8032-58D98476EAE5}" type="slidenum">
               <a:rPr lang="en-US" smtClean="0"/>
               <a:pPr/>
-              <a:t>‹N°›</a:t>
+              <a:t>‹#›</a:t>
             </a:fld>
             <a:endParaRPr lang="en-US" dirty="0"/>
           </a:p>
@@ -1891,7 +1902,7 @@
     </p:spTree>
     <p:extLst>
       <p:ext uri="{BB962C8B-B14F-4D97-AF65-F5344CB8AC3E}">
-        <p14:creationId xmlns:p14="http://schemas.microsoft.com/office/powerpoint/2010/main" xmlns="" val="2106617271"/>
+        <p14:creationId xmlns:p14="http://schemas.microsoft.com/office/powerpoint/2010/main" val="2106617271"/>
       </p:ext>
     </p:extLst>
   </p:cSld>
@@ -2118,7 +2129,7 @@
             <a:fld id="{388BEFF6-CA1E-4F2C-AB17-C8AC986E5615}" type="datetimeFigureOut">
               <a:rPr lang="en-US" smtClean="0"/>
               <a:pPr/>
-              <a:t>8/12/2024</a:t>
+              <a:t>4/10/2026</a:t>
             </a:fld>
             <a:endParaRPr lang="en-US" dirty="0"/>
           </a:p>
@@ -2161,7 +2172,7 @@
             <a:fld id="{B2B78684-98AC-4705-8032-58D98476EAE5}" type="slidenum">
               <a:rPr lang="en-US" smtClean="0"/>
               <a:pPr/>
-              <a:t>‹N°›</a:t>
+              <a:t>‹#›</a:t>
             </a:fld>
             <a:endParaRPr lang="en-US" dirty="0"/>
           </a:p>
@@ -2170,7 +2181,7 @@
     </p:spTree>
     <p:extLst>
       <p:ext uri="{BB962C8B-B14F-4D97-AF65-F5344CB8AC3E}">
-        <p14:creationId xmlns:p14="http://schemas.microsoft.com/office/powerpoint/2010/main" xmlns="" val="2943008422"/>
+        <p14:creationId xmlns:p14="http://schemas.microsoft.com/office/powerpoint/2010/main" val="2943008422"/>
       </p:ext>
     </p:extLst>
   </p:cSld>
@@ -2373,7 +2384,7 @@
             <a:fld id="{388BEFF6-CA1E-4F2C-AB17-C8AC986E5615}" type="datetimeFigureOut">
               <a:rPr lang="en-US" smtClean="0"/>
               <a:pPr/>
-              <a:t>8/12/2024</a:t>
+              <a:t>4/10/2026</a:t>
             </a:fld>
             <a:endParaRPr lang="en-US" dirty="0"/>
           </a:p>
@@ -2416,7 +2427,7 @@
             <a:fld id="{B2B78684-98AC-4705-8032-58D98476EAE5}" type="slidenum">
               <a:rPr lang="en-US" smtClean="0"/>
               <a:pPr/>
-              <a:t>‹N°›</a:t>
+              <a:t>‹#›</a:t>
             </a:fld>
             <a:endParaRPr lang="en-US" dirty="0"/>
           </a:p>
@@ -2425,7 +2436,7 @@
     </p:spTree>
     <p:extLst>
       <p:ext uri="{BB962C8B-B14F-4D97-AF65-F5344CB8AC3E}">
-        <p14:creationId xmlns:p14="http://schemas.microsoft.com/office/powerpoint/2010/main" xmlns="" val="3509189551"/>
+        <p14:creationId xmlns:p14="http://schemas.microsoft.com/office/powerpoint/2010/main" val="3509189551"/>
       </p:ext>
     </p:extLst>
   </p:cSld>
@@ -2588,7 +2599,7 @@
             <a:fld id="{388BEFF6-CA1E-4F2C-AB17-C8AC986E5615}" type="datetimeFigureOut">
               <a:rPr lang="en-US" smtClean="0"/>
               <a:pPr/>
-              <a:t>8/12/2024</a:t>
+              <a:t>4/10/2026</a:t>
             </a:fld>
             <a:endParaRPr lang="en-US" dirty="0"/>
           </a:p>
@@ -2667,7 +2678,7 @@
             <a:fld id="{B2B78684-98AC-4705-8032-58D98476EAE5}" type="slidenum">
               <a:rPr lang="en-US" smtClean="0"/>
               <a:pPr/>
-              <a:t>‹N°›</a:t>
+              <a:t>‹#›</a:t>
             </a:fld>
             <a:endParaRPr lang="en-US" dirty="0"/>
           </a:p>
@@ -2676,7 +2687,7 @@
     </p:spTree>
     <p:extLst>
       <p:ext uri="{BB962C8B-B14F-4D97-AF65-F5344CB8AC3E}">
-        <p14:creationId xmlns:p14="http://schemas.microsoft.com/office/powerpoint/2010/main" xmlns="" val="139519878"/>
+        <p14:creationId xmlns:p14="http://schemas.microsoft.com/office/powerpoint/2010/main" val="139519878"/>
       </p:ext>
     </p:extLst>
   </p:cSld>
@@ -2996,6 +3007,117 @@
       </p:grpSpPr>
       <p:sp>
         <p:nvSpPr>
+          <p:cNvPr id="256" name="Rectangle 255"/>
+          <p:cNvSpPr/>
+          <p:nvPr/>
+        </p:nvSpPr>
+        <p:spPr>
+          <a:xfrm>
+            <a:off x="0" y="0"/>
+            <a:ext cx="7162800" cy="6858000"/>
+          </a:xfrm>
+          <a:prstGeom prst="rect">
+            <a:avLst/>
+          </a:prstGeom>
+          <a:ln>
+            <a:noFill/>
+          </a:ln>
+        </p:spPr>
+        <p:style>
+          <a:lnRef idx="1">
+            <a:schemeClr val="accent6"/>
+          </a:lnRef>
+          <a:fillRef idx="2">
+            <a:schemeClr val="accent6"/>
+          </a:fillRef>
+          <a:effectRef idx="1">
+            <a:schemeClr val="accent6"/>
+          </a:effectRef>
+          <a:fontRef idx="minor">
+            <a:schemeClr val="dk1"/>
+          </a:fontRef>
+        </p:style>
+        <p:txBody>
+          <a:bodyPr rtlCol="0" anchor="t"/>
+          <a:lstStyle/>
+          <a:p>
+            <a:r>
+              <a:rPr lang="en-US" b="1" dirty="0" smtClean="0">
+                <a:solidFill>
+                  <a:schemeClr val="accent6">
+                    <a:lumMod val="75000"/>
+                  </a:schemeClr>
+                </a:solidFill>
+              </a:rPr>
+              <a:t>Primary / Driving Adapter</a:t>
+            </a:r>
+            <a:endParaRPr lang="en-US" b="1" dirty="0">
+              <a:solidFill>
+                <a:schemeClr val="accent6">
+                  <a:lumMod val="75000"/>
+                </a:schemeClr>
+              </a:solidFill>
+            </a:endParaRPr>
+          </a:p>
+        </p:txBody>
+      </p:sp>
+      <p:sp>
+        <p:nvSpPr>
+          <p:cNvPr id="207" name="Rounded Rectangle 206"/>
+          <p:cNvSpPr/>
+          <p:nvPr/>
+        </p:nvSpPr>
+        <p:spPr>
+          <a:xfrm>
+            <a:off x="1091158" y="4174964"/>
+            <a:ext cx="2390473" cy="1176671"/>
+          </a:xfrm>
+          <a:prstGeom prst="roundRect">
+            <a:avLst/>
+          </a:prstGeom>
+          <a:solidFill>
+            <a:srgbClr val="FFC000"/>
+          </a:solidFill>
+          <a:ln>
+            <a:noFill/>
+          </a:ln>
+        </p:spPr>
+        <p:style>
+          <a:lnRef idx="2">
+            <a:schemeClr val="accent1">
+              <a:shade val="50000"/>
+            </a:schemeClr>
+          </a:lnRef>
+          <a:fillRef idx="1">
+            <a:schemeClr val="accent1"/>
+          </a:fillRef>
+          <a:effectRef idx="0">
+            <a:schemeClr val="accent1"/>
+          </a:effectRef>
+          <a:fontRef idx="minor">
+            <a:schemeClr val="lt1"/>
+          </a:fontRef>
+        </p:style>
+        <p:txBody>
+          <a:bodyPr rtlCol="0" anchor="t"/>
+          <a:lstStyle/>
+          <a:p>
+            <a:r>
+              <a:rPr lang="en-US" sz="1600" b="1" dirty="0" smtClean="0"/>
+              <a:t>PROJECT</a:t>
+            </a:r>
+          </a:p>
+          <a:p>
+            <a:r>
+              <a:rPr lang="en-US" sz="1600" b="1" dirty="0" smtClean="0"/>
+              <a:t>(C99)</a:t>
+            </a:r>
+            <a:endParaRPr lang="en-US" sz="1600" b="1" dirty="0"/>
+          </a:p>
+        </p:txBody>
+      </p:sp>
+      <p:sp>
+        <p:nvSpPr>
           <p:cNvPr id="276" name="Rectangle 275"/>
           <p:cNvSpPr/>
           <p:nvPr/>
@@ -3051,62 +3173,6 @@
       </p:sp>
       <p:sp>
         <p:nvSpPr>
-          <p:cNvPr id="256" name="Rectangle 255"/>
-          <p:cNvSpPr/>
-          <p:nvPr/>
-        </p:nvSpPr>
-        <p:spPr>
-          <a:xfrm>
-            <a:off x="0" y="0"/>
-            <a:ext cx="7162800" cy="6858000"/>
-          </a:xfrm>
-          <a:prstGeom prst="rect">
-            <a:avLst/>
-          </a:prstGeom>
-          <a:ln>
-            <a:noFill/>
-          </a:ln>
-        </p:spPr>
-        <p:style>
-          <a:lnRef idx="1">
-            <a:schemeClr val="accent6"/>
-          </a:lnRef>
-          <a:fillRef idx="2">
-            <a:schemeClr val="accent6"/>
-          </a:fillRef>
-          <a:effectRef idx="1">
-            <a:schemeClr val="accent6"/>
-          </a:effectRef>
-          <a:fontRef idx="minor">
-            <a:schemeClr val="dk1"/>
-          </a:fontRef>
-        </p:style>
-        <p:txBody>
-          <a:bodyPr rtlCol="0" anchor="t"/>
-          <a:lstStyle/>
-          <a:p>
-            <a:r>
-              <a:rPr lang="en-US" b="1" dirty="0" smtClean="0">
-                <a:solidFill>
-                  <a:schemeClr val="accent6">
-                    <a:lumMod val="75000"/>
-                  </a:schemeClr>
-                </a:solidFill>
-              </a:rPr>
-              <a:t>Primary / Driving Adapter</a:t>
-            </a:r>
-            <a:endParaRPr lang="en-US" b="1" dirty="0">
-              <a:solidFill>
-                <a:schemeClr val="accent6">
-                  <a:lumMod val="75000"/>
-                </a:schemeClr>
-              </a:solidFill>
-            </a:endParaRPr>
-          </a:p>
-        </p:txBody>
-      </p:sp>
-      <p:sp>
-        <p:nvSpPr>
           <p:cNvPr id="6" name="Hexagone 5"/>
           <p:cNvSpPr/>
           <p:nvPr/>
@@ -3154,7 +3220,7 @@
         </p:nvSpPr>
         <p:spPr>
           <a:xfrm>
-            <a:off x="3989852" y="4447546"/>
+            <a:off x="3988102" y="4351020"/>
             <a:ext cx="914400" cy="182880"/>
           </a:xfrm>
           <a:prstGeom prst="rect">
@@ -3195,7 +3261,7 @@
         </p:nvSpPr>
         <p:spPr>
           <a:xfrm>
-            <a:off x="4027046" y="1519295"/>
+            <a:off x="4100513" y="1474048"/>
             <a:ext cx="914400" cy="182880"/>
           </a:xfrm>
           <a:prstGeom prst="rect">
@@ -3705,8 +3771,8 @@
         </p:nvCxnSpPr>
         <p:spPr>
           <a:xfrm>
-            <a:off x="4941446" y="1610735"/>
-            <a:ext cx="575128" cy="362398"/>
+            <a:off x="5014913" y="1565488"/>
+            <a:ext cx="501661" cy="407645"/>
           </a:xfrm>
           <a:prstGeom prst="straightConnector1">
             <a:avLst/>
@@ -5387,8 +5453,8 @@
         </p:nvCxnSpPr>
         <p:spPr>
           <a:xfrm flipV="1">
-            <a:off x="4857988" y="3076575"/>
-            <a:ext cx="314087" cy="937628"/>
+            <a:off x="5150270" y="3076575"/>
+            <a:ext cx="21805" cy="2022524"/>
           </a:xfrm>
           <a:prstGeom prst="straightConnector1">
             <a:avLst/>
@@ -5427,8 +5493,8 @@
         </p:nvCxnSpPr>
         <p:spPr>
           <a:xfrm flipV="1">
-            <a:off x="4904252" y="3076575"/>
-            <a:ext cx="267823" cy="1462411"/>
+            <a:off x="4902502" y="3076575"/>
+            <a:ext cx="269573" cy="1365885"/>
           </a:xfrm>
           <a:prstGeom prst="straightConnector1">
             <a:avLst/>
@@ -5467,8 +5533,8 @@
         </p:nvCxnSpPr>
         <p:spPr>
           <a:xfrm flipV="1">
-            <a:off x="4710125" y="3076575"/>
-            <a:ext cx="461950" cy="42736"/>
+            <a:off x="4681143" y="3076575"/>
+            <a:ext cx="490932" cy="500062"/>
           </a:xfrm>
           <a:prstGeom prst="straightConnector1">
             <a:avLst/>
@@ -5507,8 +5573,8 @@
         </p:nvCxnSpPr>
         <p:spPr>
           <a:xfrm>
-            <a:off x="4851637" y="2174069"/>
-            <a:ext cx="320438" cy="902506"/>
+            <a:off x="4765511" y="2359262"/>
+            <a:ext cx="406564" cy="717313"/>
           </a:xfrm>
           <a:prstGeom prst="straightConnector1">
             <a:avLst/>
@@ -5547,8 +5613,8 @@
         </p:nvCxnSpPr>
         <p:spPr>
           <a:xfrm>
-            <a:off x="4941446" y="1610735"/>
-            <a:ext cx="230629" cy="1465840"/>
+            <a:off x="5014913" y="1565488"/>
+            <a:ext cx="157162" cy="1511087"/>
           </a:xfrm>
           <a:prstGeom prst="straightConnector1">
             <a:avLst/>
@@ -5578,443 +5644,13 @@
       </p:cxnSp>
       <p:sp>
         <p:nvSpPr>
-          <p:cNvPr id="257" name="Hexagone 256"/>
+          <p:cNvPr id="12" name="Rectangle 11"/>
           <p:cNvSpPr/>
           <p:nvPr/>
         </p:nvSpPr>
         <p:spPr>
           <a:xfrm>
-            <a:off x="2009775" y="5425390"/>
-            <a:ext cx="1371600" cy="1188720"/>
-          </a:xfrm>
-          <a:prstGeom prst="hexagon">
-            <a:avLst/>
-          </a:prstGeom>
-          <a:solidFill>
-            <a:schemeClr val="accent1"/>
-          </a:solidFill>
-        </p:spPr>
-        <p:style>
-          <a:lnRef idx="1">
-            <a:schemeClr val="accent5"/>
-          </a:lnRef>
-          <a:fillRef idx="3">
-            <a:schemeClr val="accent5"/>
-          </a:fillRef>
-          <a:effectRef idx="2">
-            <a:schemeClr val="accent5"/>
-          </a:effectRef>
-          <a:fontRef idx="minor">
-            <a:schemeClr val="lt1"/>
-          </a:fontRef>
-        </p:style>
-        <p:txBody>
-          <a:bodyPr rtlCol="0" anchor="t"/>
-          <a:lstStyle/>
-          <a:p>
-            <a:pPr algn="ctr"/>
-            <a:r>
-              <a:rPr lang="en-US" sz="1000" b="1" dirty="0" smtClean="0"/>
-              <a:t>game_raylib5</a:t>
-            </a:r>
-            <a:endParaRPr lang="en-US" sz="1000" b="1" dirty="0"/>
-          </a:p>
-        </p:txBody>
-      </p:sp>
-      <p:sp>
-        <p:nvSpPr>
-          <p:cNvPr id="211" name="Hexagone 210"/>
-          <p:cNvSpPr/>
-          <p:nvPr/>
-        </p:nvSpPr>
-        <p:spPr>
-          <a:xfrm>
-            <a:off x="933450" y="3162300"/>
-            <a:ext cx="828676" cy="704850"/>
-          </a:xfrm>
-          <a:prstGeom prst="hexagon">
-            <a:avLst/>
-          </a:prstGeom>
-          <a:solidFill>
-            <a:schemeClr val="accent1"/>
-          </a:solidFill>
-        </p:spPr>
-        <p:style>
-          <a:lnRef idx="1">
-            <a:schemeClr val="accent5"/>
-          </a:lnRef>
-          <a:fillRef idx="3">
-            <a:schemeClr val="accent5"/>
-          </a:fillRef>
-          <a:effectRef idx="2">
-            <a:schemeClr val="accent5"/>
-          </a:effectRef>
-          <a:fontRef idx="minor">
-            <a:schemeClr val="lt1"/>
-          </a:fontRef>
-        </p:style>
-        <p:txBody>
-          <a:bodyPr rtlCol="0" anchor="ctr"/>
-          <a:lstStyle/>
-          <a:p>
-            <a:pPr algn="ctr"/>
-            <a:endParaRPr lang="en-US" dirty="0"/>
-          </a:p>
-        </p:txBody>
-      </p:sp>
-      <p:sp>
-        <p:nvSpPr>
-          <p:cNvPr id="212" name="Hexagone 211"/>
-          <p:cNvSpPr/>
-          <p:nvPr/>
-        </p:nvSpPr>
-        <p:spPr>
-          <a:xfrm>
-            <a:off x="971550" y="1924050"/>
-            <a:ext cx="828676" cy="704850"/>
-          </a:xfrm>
-          <a:prstGeom prst="hexagon">
-            <a:avLst/>
-          </a:prstGeom>
-          <a:solidFill>
-            <a:schemeClr val="accent1"/>
-          </a:solidFill>
-        </p:spPr>
-        <p:style>
-          <a:lnRef idx="1">
-            <a:schemeClr val="accent5"/>
-          </a:lnRef>
-          <a:fillRef idx="3">
-            <a:schemeClr val="accent5"/>
-          </a:fillRef>
-          <a:effectRef idx="2">
-            <a:schemeClr val="accent5"/>
-          </a:effectRef>
-          <a:fontRef idx="minor">
-            <a:schemeClr val="lt1"/>
-          </a:fontRef>
-        </p:style>
-        <p:txBody>
-          <a:bodyPr rtlCol="0" anchor="ctr"/>
-          <a:lstStyle/>
-          <a:p>
-            <a:pPr algn="ctr"/>
-            <a:endParaRPr lang="en-US" dirty="0"/>
-          </a:p>
-        </p:txBody>
-      </p:sp>
-      <p:sp>
-        <p:nvSpPr>
-          <p:cNvPr id="213" name="Hexagone 212"/>
-          <p:cNvSpPr/>
-          <p:nvPr/>
-        </p:nvSpPr>
-        <p:spPr>
-          <a:xfrm>
-            <a:off x="1152525" y="847725"/>
-            <a:ext cx="828676" cy="704850"/>
-          </a:xfrm>
-          <a:prstGeom prst="hexagon">
-            <a:avLst/>
-          </a:prstGeom>
-          <a:solidFill>
-            <a:schemeClr val="accent1"/>
-          </a:solidFill>
-        </p:spPr>
-        <p:style>
-          <a:lnRef idx="1">
-            <a:schemeClr val="accent5"/>
-          </a:lnRef>
-          <a:fillRef idx="3">
-            <a:schemeClr val="accent5"/>
-          </a:fillRef>
-          <a:effectRef idx="2">
-            <a:schemeClr val="accent5"/>
-          </a:effectRef>
-          <a:fontRef idx="minor">
-            <a:schemeClr val="lt1"/>
-          </a:fontRef>
-        </p:style>
-        <p:txBody>
-          <a:bodyPr rtlCol="0" anchor="ctr"/>
-          <a:lstStyle/>
-          <a:p>
-            <a:pPr algn="ctr"/>
-            <a:endParaRPr lang="en-US" dirty="0"/>
-          </a:p>
-        </p:txBody>
-      </p:sp>
-      <p:sp>
-        <p:nvSpPr>
-          <p:cNvPr id="210" name="Hexagone 209"/>
-          <p:cNvSpPr/>
-          <p:nvPr/>
-        </p:nvSpPr>
-        <p:spPr>
-          <a:xfrm>
-            <a:off x="971550" y="4381500"/>
-            <a:ext cx="828676" cy="704850"/>
-          </a:xfrm>
-          <a:prstGeom prst="hexagon">
-            <a:avLst/>
-          </a:prstGeom>
-          <a:solidFill>
-            <a:schemeClr val="accent1"/>
-          </a:solidFill>
-        </p:spPr>
-        <p:style>
-          <a:lnRef idx="1">
-            <a:schemeClr val="accent5"/>
-          </a:lnRef>
-          <a:fillRef idx="3">
-            <a:schemeClr val="accent5"/>
-          </a:fillRef>
-          <a:effectRef idx="2">
-            <a:schemeClr val="accent5"/>
-          </a:effectRef>
-          <a:fontRef idx="minor">
-            <a:schemeClr val="lt1"/>
-          </a:fontRef>
-        </p:style>
-        <p:txBody>
-          <a:bodyPr rtlCol="0" anchor="ctr"/>
-          <a:lstStyle/>
-          <a:p>
-            <a:pPr algn="ctr"/>
-            <a:endParaRPr lang="en-US" dirty="0"/>
-          </a:p>
-        </p:txBody>
-      </p:sp>
-      <p:sp>
-        <p:nvSpPr>
-          <p:cNvPr id="34" name="Hexagone 33"/>
-          <p:cNvSpPr/>
-          <p:nvPr/>
-        </p:nvSpPr>
-        <p:spPr>
-          <a:xfrm>
-            <a:off x="2105025" y="1691590"/>
-            <a:ext cx="1400175" cy="1165910"/>
-          </a:xfrm>
-          <a:prstGeom prst="hexagon">
-            <a:avLst/>
-          </a:prstGeom>
-          <a:solidFill>
-            <a:schemeClr val="accent1"/>
-          </a:solidFill>
-        </p:spPr>
-        <p:style>
-          <a:lnRef idx="1">
-            <a:schemeClr val="accent5"/>
-          </a:lnRef>
-          <a:fillRef idx="3">
-            <a:schemeClr val="accent5"/>
-          </a:fillRef>
-          <a:effectRef idx="2">
-            <a:schemeClr val="accent5"/>
-          </a:effectRef>
-          <a:fontRef idx="minor">
-            <a:schemeClr val="lt1"/>
-          </a:fontRef>
-        </p:style>
-        <p:txBody>
-          <a:bodyPr rtlCol="0" anchor="t"/>
-          <a:lstStyle/>
-          <a:p>
-            <a:pPr algn="ctr"/>
-            <a:r>
-              <a:rPr lang="en-US" sz="1000" b="1" dirty="0" smtClean="0"/>
-              <a:t>game_unity6</a:t>
-            </a:r>
-            <a:endParaRPr lang="en-US" sz="1000" b="1" dirty="0"/>
-          </a:p>
-        </p:txBody>
-      </p:sp>
-      <p:sp>
-        <p:nvSpPr>
-          <p:cNvPr id="35" name="Hexagone 34"/>
-          <p:cNvSpPr/>
-          <p:nvPr/>
-        </p:nvSpPr>
-        <p:spPr>
-          <a:xfrm>
-            <a:off x="1943100" y="2929840"/>
-            <a:ext cx="1400175" cy="1165910"/>
-          </a:xfrm>
-          <a:prstGeom prst="hexagon">
-            <a:avLst/>
-          </a:prstGeom>
-          <a:solidFill>
-            <a:schemeClr val="accent1"/>
-          </a:solidFill>
-        </p:spPr>
-        <p:style>
-          <a:lnRef idx="1">
-            <a:schemeClr val="accent5"/>
-          </a:lnRef>
-          <a:fillRef idx="3">
-            <a:schemeClr val="accent5"/>
-          </a:fillRef>
-          <a:effectRef idx="2">
-            <a:schemeClr val="accent5"/>
-          </a:effectRef>
-          <a:fontRef idx="minor">
-            <a:schemeClr val="lt1"/>
-          </a:fontRef>
-        </p:style>
-        <p:txBody>
-          <a:bodyPr rtlCol="0" anchor="t"/>
-          <a:lstStyle/>
-          <a:p>
-            <a:pPr algn="ctr"/>
-            <a:r>
-              <a:rPr lang="en-US" sz="1000" b="1" dirty="0" smtClean="0"/>
-              <a:t>game_godot4</a:t>
-            </a:r>
-            <a:endParaRPr lang="en-US" sz="1000" b="1" dirty="0"/>
-          </a:p>
-        </p:txBody>
-      </p:sp>
-      <p:sp>
-        <p:nvSpPr>
-          <p:cNvPr id="36" name="Hexagone 35"/>
-          <p:cNvSpPr/>
-          <p:nvPr/>
-        </p:nvSpPr>
-        <p:spPr>
-          <a:xfrm>
-            <a:off x="1981200" y="4177615"/>
-            <a:ext cx="1400175" cy="1165910"/>
-          </a:xfrm>
-          <a:prstGeom prst="hexagon">
-            <a:avLst/>
-          </a:prstGeom>
-          <a:solidFill>
-            <a:schemeClr val="accent1"/>
-          </a:solidFill>
-        </p:spPr>
-        <p:style>
-          <a:lnRef idx="1">
-            <a:schemeClr val="accent5"/>
-          </a:lnRef>
-          <a:fillRef idx="3">
-            <a:schemeClr val="accent5"/>
-          </a:fillRef>
-          <a:effectRef idx="2">
-            <a:schemeClr val="accent5"/>
-          </a:effectRef>
-          <a:fontRef idx="minor">
-            <a:schemeClr val="lt1"/>
-          </a:fontRef>
-        </p:style>
-        <p:txBody>
-          <a:bodyPr rtlCol="0" anchor="t"/>
-          <a:lstStyle/>
-          <a:p>
-            <a:pPr algn="ctr"/>
-            <a:r>
-              <a:rPr lang="en-US" sz="1000" b="1" dirty="0" smtClean="0"/>
-              <a:t>game_defold1</a:t>
-            </a:r>
-            <a:endParaRPr lang="en-US" sz="1000" b="1" dirty="0"/>
-          </a:p>
-        </p:txBody>
-      </p:sp>
-      <p:sp>
-        <p:nvSpPr>
-          <p:cNvPr id="37" name="Hexagone 36"/>
-          <p:cNvSpPr/>
-          <p:nvPr/>
-        </p:nvSpPr>
-        <p:spPr>
-          <a:xfrm>
-            <a:off x="3581400" y="4939615"/>
-            <a:ext cx="1371600" cy="1188720"/>
-          </a:xfrm>
-          <a:prstGeom prst="hexagon">
-            <a:avLst/>
-          </a:prstGeom>
-          <a:solidFill>
-            <a:schemeClr val="accent1"/>
-          </a:solidFill>
-        </p:spPr>
-        <p:style>
-          <a:lnRef idx="1">
-            <a:schemeClr val="accent5"/>
-          </a:lnRef>
-          <a:fillRef idx="3">
-            <a:schemeClr val="accent5"/>
-          </a:fillRef>
-          <a:effectRef idx="2">
-            <a:schemeClr val="accent5"/>
-          </a:effectRef>
-          <a:fontRef idx="minor">
-            <a:schemeClr val="lt1"/>
-          </a:fontRef>
-        </p:style>
-        <p:txBody>
-          <a:bodyPr rtlCol="0" anchor="ctr"/>
-          <a:lstStyle/>
-          <a:p>
-            <a:pPr algn="ctr"/>
-            <a:endParaRPr lang="en-US" dirty="0"/>
-          </a:p>
-        </p:txBody>
-      </p:sp>
-      <p:sp>
-        <p:nvSpPr>
-          <p:cNvPr id="32" name="Hexagone 31"/>
-          <p:cNvSpPr/>
-          <p:nvPr/>
-        </p:nvSpPr>
-        <p:spPr>
-          <a:xfrm>
-            <a:off x="2400300" y="472390"/>
-            <a:ext cx="1400175" cy="1165910"/>
-          </a:xfrm>
-          <a:prstGeom prst="hexagon">
-            <a:avLst/>
-          </a:prstGeom>
-          <a:solidFill>
-            <a:schemeClr val="accent1"/>
-          </a:solidFill>
-        </p:spPr>
-        <p:style>
-          <a:lnRef idx="1">
-            <a:schemeClr val="accent5"/>
-          </a:lnRef>
-          <a:fillRef idx="3">
-            <a:schemeClr val="accent5"/>
-          </a:fillRef>
-          <a:effectRef idx="2">
-            <a:schemeClr val="accent5"/>
-          </a:effectRef>
-          <a:fontRef idx="minor">
-            <a:schemeClr val="lt1"/>
-          </a:fontRef>
-        </p:style>
-        <p:txBody>
-          <a:bodyPr rtlCol="0" anchor="t"/>
-          <a:lstStyle/>
-          <a:p>
-            <a:pPr algn="ctr"/>
-            <a:r>
-              <a:rPr lang="en-US" sz="1000" b="1" dirty="0" smtClean="0"/>
-              <a:t>game_unreal5</a:t>
-            </a:r>
-            <a:endParaRPr lang="en-US" sz="1000" b="1" dirty="0"/>
-          </a:p>
-        </p:txBody>
-      </p:sp>
-      <p:sp>
-        <p:nvSpPr>
-          <p:cNvPr id="9" name="Rectangle 8"/>
-          <p:cNvSpPr/>
-          <p:nvPr/>
-        </p:nvSpPr>
-        <p:spPr>
-          <a:xfrm>
-            <a:off x="2226556" y="5904491"/>
+            <a:off x="3851111" y="2267822"/>
             <a:ext cx="914400" cy="182880"/>
           </a:xfrm>
           <a:prstGeom prst="rect">
@@ -6041,7 +5677,7 @@
           <a:p>
             <a:r>
               <a:rPr lang="en-US" sz="800" dirty="0" smtClean="0"/>
-              <a:t>RAYLIB5_MAIN</a:t>
+              <a:t>ENG_UNITY6</a:t>
             </a:r>
             <a:endParaRPr lang="en-US" sz="800" dirty="0"/>
           </a:p>
@@ -6049,13 +5685,13 @@
       </p:sp>
       <p:sp>
         <p:nvSpPr>
-          <p:cNvPr id="12" name="Rectangle 11"/>
+          <p:cNvPr id="13" name="Rectangle 12"/>
           <p:cNvSpPr/>
           <p:nvPr/>
         </p:nvSpPr>
         <p:spPr>
           <a:xfrm>
-            <a:off x="3937237" y="2082629"/>
+            <a:off x="3766743" y="3485197"/>
             <a:ext cx="914400" cy="182880"/>
           </a:xfrm>
           <a:prstGeom prst="rect">
@@ -6082,7 +5718,7 @@
           <a:p>
             <a:r>
               <a:rPr lang="en-US" sz="800" dirty="0" smtClean="0"/>
-              <a:t>ENG_UNITY6</a:t>
+              <a:t>ENG_GODOT4</a:t>
             </a:r>
             <a:endParaRPr lang="en-US" sz="800" dirty="0"/>
           </a:p>
@@ -6090,13 +5726,13 @@
       </p:sp>
       <p:sp>
         <p:nvSpPr>
-          <p:cNvPr id="13" name="Rectangle 12"/>
+          <p:cNvPr id="18" name="Rectangle 17"/>
           <p:cNvSpPr/>
           <p:nvPr/>
         </p:nvSpPr>
         <p:spPr>
           <a:xfrm>
-            <a:off x="3795725" y="3027871"/>
+            <a:off x="4235870" y="5007659"/>
             <a:ext cx="914400" cy="182880"/>
           </a:xfrm>
           <a:prstGeom prst="rect">
@@ -6123,220 +5759,215 @@
           <a:p>
             <a:r>
               <a:rPr lang="en-US" sz="800" dirty="0" smtClean="0"/>
-              <a:t>ENG_GODOT4</a:t>
+              <a:t>ENG_SDL3</a:t>
             </a:r>
             <a:endParaRPr lang="en-US" sz="800" dirty="0"/>
           </a:p>
         </p:txBody>
       </p:sp>
-      <p:sp>
-        <p:nvSpPr>
-          <p:cNvPr id="14" name="Rectangle 13"/>
-          <p:cNvSpPr/>
-          <p:nvPr/>
-        </p:nvSpPr>
-        <p:spPr>
-          <a:xfrm>
-            <a:off x="2225008" y="3344459"/>
-            <a:ext cx="914400" cy="182880"/>
-          </a:xfrm>
-          <a:prstGeom prst="rect">
-            <a:avLst/>
-          </a:prstGeom>
-        </p:spPr>
-        <p:style>
-          <a:lnRef idx="2">
-            <a:schemeClr val="accent1"/>
-          </a:lnRef>
-          <a:fillRef idx="1">
-            <a:schemeClr val="lt1"/>
-          </a:fillRef>
-          <a:effectRef idx="0">
-            <a:schemeClr val="accent1"/>
-          </a:effectRef>
-          <a:fontRef idx="minor">
-            <a:schemeClr val="dk1"/>
-          </a:fontRef>
-        </p:style>
-        <p:txBody>
-          <a:bodyPr rtlCol="0" anchor="ctr"/>
-          <a:lstStyle/>
-          <a:p>
-            <a:r>
-              <a:rPr lang="en-US" sz="800" dirty="0" smtClean="0"/>
-              <a:t>GODOT4_SCRIPT</a:t>
-            </a:r>
-            <a:endParaRPr lang="en-US" sz="800" dirty="0"/>
-          </a:p>
-        </p:txBody>
-      </p:sp>
-      <p:sp>
-        <p:nvSpPr>
-          <p:cNvPr id="15" name="Rectangle 14"/>
-          <p:cNvSpPr/>
-          <p:nvPr/>
-        </p:nvSpPr>
-        <p:spPr>
-          <a:xfrm>
-            <a:off x="2389198" y="2108477"/>
-            <a:ext cx="914400" cy="182880"/>
-          </a:xfrm>
-          <a:prstGeom prst="rect">
-            <a:avLst/>
-          </a:prstGeom>
-        </p:spPr>
-        <p:style>
-          <a:lnRef idx="2">
-            <a:schemeClr val="accent1"/>
-          </a:lnRef>
-          <a:fillRef idx="1">
-            <a:schemeClr val="lt1"/>
-          </a:fillRef>
-          <a:effectRef idx="0">
-            <a:schemeClr val="accent1"/>
-          </a:effectRef>
-          <a:fontRef idx="minor">
-            <a:schemeClr val="dk1"/>
-          </a:fontRef>
-        </p:style>
-        <p:txBody>
-          <a:bodyPr rtlCol="0" anchor="ctr"/>
-          <a:lstStyle/>
-          <a:p>
-            <a:r>
-              <a:rPr lang="en-US" sz="800" dirty="0" smtClean="0"/>
-              <a:t>UNITY6_SCRIPT</a:t>
-            </a:r>
-            <a:endParaRPr lang="en-US" sz="800" dirty="0"/>
-          </a:p>
-        </p:txBody>
-      </p:sp>
-      <p:sp>
-        <p:nvSpPr>
-          <p:cNvPr id="16" name="Rectangle 15"/>
-          <p:cNvSpPr/>
-          <p:nvPr/>
-        </p:nvSpPr>
-        <p:spPr>
-          <a:xfrm>
-            <a:off x="2666786" y="892453"/>
-            <a:ext cx="914400" cy="182880"/>
-          </a:xfrm>
-          <a:prstGeom prst="rect">
-            <a:avLst/>
-          </a:prstGeom>
-        </p:spPr>
-        <p:style>
-          <a:lnRef idx="2">
-            <a:schemeClr val="accent1"/>
-          </a:lnRef>
-          <a:fillRef idx="1">
-            <a:schemeClr val="lt1"/>
-          </a:fillRef>
-          <a:effectRef idx="0">
-            <a:schemeClr val="accent1"/>
-          </a:effectRef>
-          <a:fontRef idx="minor">
-            <a:schemeClr val="dk1"/>
-          </a:fontRef>
-        </p:style>
-        <p:txBody>
-          <a:bodyPr rtlCol="0" anchor="ctr"/>
-          <a:lstStyle/>
-          <a:p>
-            <a:r>
-              <a:rPr lang="en-US" sz="800" dirty="0" smtClean="0"/>
-              <a:t>UNREAL5_SCRIPT</a:t>
-            </a:r>
-            <a:endParaRPr lang="en-US" sz="800" dirty="0"/>
-          </a:p>
-        </p:txBody>
-      </p:sp>
-      <p:sp>
-        <p:nvSpPr>
-          <p:cNvPr id="17" name="Rectangle 16"/>
-          <p:cNvSpPr/>
-          <p:nvPr/>
-        </p:nvSpPr>
-        <p:spPr>
-          <a:xfrm>
-            <a:off x="2257397" y="4608182"/>
-            <a:ext cx="914400" cy="182880"/>
-          </a:xfrm>
-          <a:prstGeom prst="rect">
-            <a:avLst/>
-          </a:prstGeom>
-        </p:spPr>
-        <p:style>
-          <a:lnRef idx="2">
-            <a:schemeClr val="accent1"/>
-          </a:lnRef>
-          <a:fillRef idx="1">
-            <a:schemeClr val="lt1"/>
-          </a:fillRef>
-          <a:effectRef idx="0">
-            <a:schemeClr val="accent1"/>
-          </a:effectRef>
-          <a:fontRef idx="minor">
-            <a:schemeClr val="dk1"/>
-          </a:fontRef>
-        </p:style>
-        <p:txBody>
-          <a:bodyPr rtlCol="0" anchor="ctr"/>
-          <a:lstStyle/>
-          <a:p>
-            <a:r>
-              <a:rPr lang="en-US" sz="800" dirty="0" smtClean="0"/>
-              <a:t>DEFOLD1_SCRIPT</a:t>
-            </a:r>
-            <a:endParaRPr lang="en-US" sz="800" dirty="0"/>
-          </a:p>
-        </p:txBody>
-      </p:sp>
-      <p:sp>
-        <p:nvSpPr>
-          <p:cNvPr id="18" name="Rectangle 17"/>
-          <p:cNvSpPr/>
-          <p:nvPr/>
-        </p:nvSpPr>
-        <p:spPr>
-          <a:xfrm>
-            <a:off x="3943588" y="3922763"/>
-            <a:ext cx="914400" cy="182880"/>
-          </a:xfrm>
-          <a:prstGeom prst="rect">
-            <a:avLst/>
-          </a:prstGeom>
-        </p:spPr>
-        <p:style>
-          <a:lnRef idx="2">
-            <a:schemeClr val="accent1"/>
-          </a:lnRef>
-          <a:fillRef idx="1">
-            <a:schemeClr val="lt1"/>
-          </a:fillRef>
-          <a:effectRef idx="0">
-            <a:schemeClr val="accent1"/>
-          </a:effectRef>
-          <a:fontRef idx="minor">
-            <a:schemeClr val="dk1"/>
-          </a:fontRef>
-        </p:style>
-        <p:txBody>
-          <a:bodyPr rtlCol="0" anchor="ctr"/>
-          <a:lstStyle/>
-          <a:p>
-            <a:r>
-              <a:rPr lang="en-US" sz="800" dirty="0" smtClean="0"/>
-              <a:t>ENG_DEFOLD1</a:t>
-            </a:r>
-            <a:endParaRPr lang="en-US" sz="800" dirty="0"/>
-          </a:p>
-        </p:txBody>
-      </p:sp>
+      <p:cxnSp>
+        <p:nvCxnSpPr>
+          <p:cNvPr id="322" name="Connecteur droit avec flèche 321"/>
+          <p:cNvCxnSpPr>
+            <a:stCxn id="1032" idx="2"/>
+            <a:endCxn id="208" idx="1"/>
+          </p:cNvCxnSpPr>
+          <p:nvPr/>
+        </p:nvCxnSpPr>
+        <p:spPr>
+          <a:xfrm flipV="1">
+            <a:off x="385763" y="1004932"/>
+            <a:ext cx="712865" cy="2318332"/>
+          </a:xfrm>
+          <a:prstGeom prst="straightConnector1">
+            <a:avLst/>
+          </a:prstGeom>
+          <a:ln w="38100">
+            <a:solidFill>
+              <a:schemeClr val="tx1"/>
+            </a:solidFill>
+            <a:headEnd type="none" w="med" len="med"/>
+            <a:tailEnd type="triangle" w="med" len="med"/>
+          </a:ln>
+        </p:spPr>
+        <p:style>
+          <a:lnRef idx="3">
+            <a:schemeClr val="dk1"/>
+          </a:lnRef>
+          <a:fillRef idx="0">
+            <a:schemeClr val="dk1"/>
+          </a:fillRef>
+          <a:effectRef idx="2">
+            <a:schemeClr val="dk1"/>
+          </a:effectRef>
+          <a:fontRef idx="minor">
+            <a:schemeClr val="tx1"/>
+          </a:fontRef>
+        </p:style>
+      </p:cxnSp>
+      <p:cxnSp>
+        <p:nvCxnSpPr>
+          <p:cNvPr id="325" name="Connecteur droit avec flèche 324"/>
+          <p:cNvCxnSpPr>
+            <a:stCxn id="1032" idx="2"/>
+            <a:endCxn id="220" idx="1"/>
+          </p:cNvCxnSpPr>
+          <p:nvPr/>
+        </p:nvCxnSpPr>
+        <p:spPr>
+          <a:xfrm flipV="1">
+            <a:off x="385763" y="2252681"/>
+            <a:ext cx="710280" cy="1070583"/>
+          </a:xfrm>
+          <a:prstGeom prst="straightConnector1">
+            <a:avLst/>
+          </a:prstGeom>
+          <a:ln w="38100">
+            <a:solidFill>
+              <a:schemeClr val="tx1"/>
+            </a:solidFill>
+            <a:headEnd type="none" w="med" len="med"/>
+            <a:tailEnd type="triangle" w="med" len="med"/>
+          </a:ln>
+        </p:spPr>
+        <p:style>
+          <a:lnRef idx="3">
+            <a:schemeClr val="dk1"/>
+          </a:lnRef>
+          <a:fillRef idx="0">
+            <a:schemeClr val="dk1"/>
+          </a:fillRef>
+          <a:effectRef idx="2">
+            <a:schemeClr val="dk1"/>
+          </a:effectRef>
+          <a:fontRef idx="minor">
+            <a:schemeClr val="tx1"/>
+          </a:fontRef>
+        </p:style>
+      </p:cxnSp>
+      <p:cxnSp>
+        <p:nvCxnSpPr>
+          <p:cNvPr id="328" name="Connecteur droit avec flèche 327"/>
+          <p:cNvCxnSpPr>
+            <a:stCxn id="1032" idx="2"/>
+            <a:endCxn id="230" idx="1"/>
+          </p:cNvCxnSpPr>
+          <p:nvPr/>
+        </p:nvCxnSpPr>
+        <p:spPr>
+          <a:xfrm>
+            <a:off x="385763" y="3323264"/>
+            <a:ext cx="718468" cy="192570"/>
+          </a:xfrm>
+          <a:prstGeom prst="straightConnector1">
+            <a:avLst/>
+          </a:prstGeom>
+          <a:ln w="38100">
+            <a:solidFill>
+              <a:schemeClr val="tx1"/>
+            </a:solidFill>
+            <a:headEnd type="none" w="med" len="med"/>
+            <a:tailEnd type="triangle" w="med" len="med"/>
+          </a:ln>
+        </p:spPr>
+        <p:style>
+          <a:lnRef idx="3">
+            <a:schemeClr val="dk1"/>
+          </a:lnRef>
+          <a:fillRef idx="0">
+            <a:schemeClr val="dk1"/>
+          </a:fillRef>
+          <a:effectRef idx="2">
+            <a:schemeClr val="dk1"/>
+          </a:effectRef>
+          <a:fontRef idx="minor">
+            <a:schemeClr val="tx1"/>
+          </a:fontRef>
+        </p:style>
+      </p:cxnSp>
+      <p:cxnSp>
+        <p:nvCxnSpPr>
+          <p:cNvPr id="331" name="Connecteur droit avec flèche 330"/>
+          <p:cNvCxnSpPr>
+            <a:stCxn id="1032" idx="2"/>
+            <a:endCxn id="236" idx="1"/>
+          </p:cNvCxnSpPr>
+          <p:nvPr/>
+        </p:nvCxnSpPr>
+        <p:spPr>
+          <a:xfrm>
+            <a:off x="385763" y="3323264"/>
+            <a:ext cx="722610" cy="2729629"/>
+          </a:xfrm>
+          <a:prstGeom prst="straightConnector1">
+            <a:avLst/>
+          </a:prstGeom>
+          <a:ln w="38100">
+            <a:solidFill>
+              <a:schemeClr val="tx1"/>
+            </a:solidFill>
+            <a:headEnd type="none" w="med" len="med"/>
+            <a:tailEnd type="triangle" w="med" len="med"/>
+          </a:ln>
+        </p:spPr>
+        <p:style>
+          <a:lnRef idx="3">
+            <a:schemeClr val="dk1"/>
+          </a:lnRef>
+          <a:fillRef idx="0">
+            <a:schemeClr val="dk1"/>
+          </a:fillRef>
+          <a:effectRef idx="2">
+            <a:schemeClr val="dk1"/>
+          </a:effectRef>
+          <a:fontRef idx="minor">
+            <a:schemeClr val="tx1"/>
+          </a:fontRef>
+        </p:style>
+      </p:cxnSp>
+      <p:cxnSp>
+        <p:nvCxnSpPr>
+          <p:cNvPr id="334" name="Connecteur droit avec flèche 333"/>
+          <p:cNvCxnSpPr>
+            <a:stCxn id="1032" idx="2"/>
+            <a:endCxn id="207" idx="1"/>
+          </p:cNvCxnSpPr>
+          <p:nvPr/>
+        </p:nvCxnSpPr>
+        <p:spPr>
+          <a:xfrm>
+            <a:off x="385763" y="3323264"/>
+            <a:ext cx="705395" cy="1440036"/>
+          </a:xfrm>
+          <a:prstGeom prst="straightConnector1">
+            <a:avLst/>
+          </a:prstGeom>
+          <a:ln w="38100">
+            <a:solidFill>
+              <a:schemeClr val="tx1"/>
+            </a:solidFill>
+            <a:headEnd type="none" w="med" len="med"/>
+            <a:tailEnd type="triangle" w="med" len="med"/>
+          </a:ln>
+        </p:spPr>
+        <p:style>
+          <a:lnRef idx="3">
+            <a:schemeClr val="dk1"/>
+          </a:lnRef>
+          <a:fillRef idx="0">
+            <a:schemeClr val="dk1"/>
+          </a:fillRef>
+          <a:effectRef idx="2">
+            <a:schemeClr val="dk1"/>
+          </a:effectRef>
+          <a:fontRef idx="minor">
+            <a:schemeClr val="tx1"/>
+          </a:fontRef>
+        </p:style>
+      </p:cxnSp>
       <p:pic>
         <p:nvPicPr>
-          <p:cNvPr id="33" name="Picture 2"/>
+          <p:cNvPr id="1032" name="Picture 8" descr="User - Avatar &amp; Emoticons Icons"/>
           <p:cNvPicPr>
             <a:picLocks noChangeAspect="1" noChangeArrowheads="1"/>
           </p:cNvPicPr>
@@ -6351,1057 +5982,7 @@
         </p:blipFill>
         <p:spPr bwMode="auto">
           <a:xfrm>
-            <a:off x="1358557" y="994573"/>
-            <a:ext cx="455518" cy="425371"/>
-          </a:xfrm>
-          <a:prstGeom prst="rect">
-            <a:avLst/>
-          </a:prstGeom>
-          <a:noFill/>
-          <a:ln w="9525">
-            <a:noFill/>
-            <a:miter lim="800000"/>
-            <a:headEnd/>
-            <a:tailEnd/>
-          </a:ln>
-          <a:effectLst/>
-        </p:spPr>
-      </p:pic>
-      <p:pic>
-        <p:nvPicPr>
-          <p:cNvPr id="38" name="Picture 3"/>
-          <p:cNvPicPr>
-            <a:picLocks noChangeAspect="1" noChangeArrowheads="1"/>
-          </p:cNvPicPr>
-          <p:nvPr/>
-        </p:nvPicPr>
-        <p:blipFill>
-          <a:blip r:embed="rId5" cstate="print"/>
-          <a:srcRect/>
-          <a:stretch>
-            <a:fillRect/>
-          </a:stretch>
-        </p:blipFill>
-        <p:spPr bwMode="auto">
-          <a:xfrm>
-            <a:off x="1164452" y="2039720"/>
-            <a:ext cx="401327" cy="454577"/>
-          </a:xfrm>
-          <a:prstGeom prst="rect">
-            <a:avLst/>
-          </a:prstGeom>
-          <a:noFill/>
-          <a:ln w="9525">
-            <a:noFill/>
-            <a:miter lim="800000"/>
-            <a:headEnd/>
-            <a:tailEnd/>
-          </a:ln>
-          <a:effectLst/>
-        </p:spPr>
-      </p:pic>
-      <p:pic>
-        <p:nvPicPr>
-          <p:cNvPr id="39" name="Picture 5"/>
-          <p:cNvPicPr>
-            <a:picLocks noChangeAspect="1" noChangeArrowheads="1"/>
-          </p:cNvPicPr>
-          <p:nvPr/>
-        </p:nvPicPr>
-        <p:blipFill>
-          <a:blip r:embed="rId6" cstate="print"/>
-          <a:srcRect/>
-          <a:stretch>
-            <a:fillRect/>
-          </a:stretch>
-        </p:blipFill>
-        <p:spPr bwMode="auto">
-          <a:xfrm>
-            <a:off x="1129442" y="3280959"/>
-            <a:ext cx="470329" cy="484276"/>
-          </a:xfrm>
-          <a:prstGeom prst="rect">
-            <a:avLst/>
-          </a:prstGeom>
-          <a:noFill/>
-          <a:ln w="9525">
-            <a:noFill/>
-            <a:miter lim="800000"/>
-            <a:headEnd/>
-            <a:tailEnd/>
-          </a:ln>
-          <a:effectLst/>
-        </p:spPr>
-      </p:pic>
-      <p:pic>
-        <p:nvPicPr>
-          <p:cNvPr id="40" name="Picture 6"/>
-          <p:cNvPicPr>
-            <a:picLocks noChangeAspect="1" noChangeArrowheads="1"/>
-          </p:cNvPicPr>
-          <p:nvPr/>
-        </p:nvPicPr>
-        <p:blipFill>
-          <a:blip r:embed="rId7" cstate="print"/>
-          <a:srcRect/>
-          <a:stretch>
-            <a:fillRect/>
-          </a:stretch>
-        </p:blipFill>
-        <p:spPr bwMode="auto">
-          <a:xfrm>
-            <a:off x="1133303" y="4496552"/>
-            <a:ext cx="530825" cy="469206"/>
-          </a:xfrm>
-          <a:prstGeom prst="rect">
-            <a:avLst/>
-          </a:prstGeom>
-          <a:noFill/>
-          <a:ln w="9525">
-            <a:noFill/>
-            <a:miter lim="800000"/>
-            <a:headEnd/>
-            <a:tailEnd/>
-          </a:ln>
-          <a:effectLst/>
-        </p:spPr>
-      </p:pic>
-      <p:cxnSp>
-        <p:nvCxnSpPr>
-          <p:cNvPr id="43" name="Connecteur droit avec flèche 42"/>
-          <p:cNvCxnSpPr>
-            <a:stCxn id="16" idx="3"/>
-            <a:endCxn id="11" idx="1"/>
-          </p:cNvCxnSpPr>
-          <p:nvPr/>
-        </p:nvCxnSpPr>
-        <p:spPr>
-          <a:xfrm>
-            <a:off x="3581186" y="983893"/>
-            <a:ext cx="445860" cy="626842"/>
-          </a:xfrm>
-          <a:prstGeom prst="straightConnector1">
-            <a:avLst/>
-          </a:prstGeom>
-          <a:ln w="38100">
-            <a:solidFill>
-              <a:schemeClr val="tx1"/>
-            </a:solidFill>
-            <a:headEnd type="none" w="med" len="med"/>
-            <a:tailEnd type="triangle" w="med" len="med"/>
-          </a:ln>
-        </p:spPr>
-        <p:style>
-          <a:lnRef idx="3">
-            <a:schemeClr val="dk1"/>
-          </a:lnRef>
-          <a:fillRef idx="0">
-            <a:schemeClr val="dk1"/>
-          </a:fillRef>
-          <a:effectRef idx="2">
-            <a:schemeClr val="dk1"/>
-          </a:effectRef>
-          <a:fontRef idx="minor">
-            <a:schemeClr val="tx1"/>
-          </a:fontRef>
-        </p:style>
-      </p:cxnSp>
-      <p:cxnSp>
-        <p:nvCxnSpPr>
-          <p:cNvPr id="45" name="Connecteur droit avec flèche 44"/>
-          <p:cNvCxnSpPr>
-            <a:stCxn id="15" idx="3"/>
-            <a:endCxn id="12" idx="1"/>
-          </p:cNvCxnSpPr>
-          <p:nvPr/>
-        </p:nvCxnSpPr>
-        <p:spPr>
-          <a:xfrm flipV="1">
-            <a:off x="3303598" y="2174069"/>
-            <a:ext cx="633639" cy="25848"/>
-          </a:xfrm>
-          <a:prstGeom prst="straightConnector1">
-            <a:avLst/>
-          </a:prstGeom>
-          <a:ln w="38100">
-            <a:solidFill>
-              <a:schemeClr val="tx1"/>
-            </a:solidFill>
-            <a:headEnd type="none" w="med" len="med"/>
-            <a:tailEnd type="triangle" w="med" len="med"/>
-          </a:ln>
-        </p:spPr>
-        <p:style>
-          <a:lnRef idx="3">
-            <a:schemeClr val="dk1"/>
-          </a:lnRef>
-          <a:fillRef idx="0">
-            <a:schemeClr val="dk1"/>
-          </a:fillRef>
-          <a:effectRef idx="2">
-            <a:schemeClr val="dk1"/>
-          </a:effectRef>
-          <a:fontRef idx="minor">
-            <a:schemeClr val="tx1"/>
-          </a:fontRef>
-        </p:style>
-      </p:cxnSp>
-      <p:cxnSp>
-        <p:nvCxnSpPr>
-          <p:cNvPr id="48" name="Connecteur droit avec flèche 47"/>
-          <p:cNvCxnSpPr>
-            <a:stCxn id="14" idx="3"/>
-            <a:endCxn id="13" idx="1"/>
-          </p:cNvCxnSpPr>
-          <p:nvPr/>
-        </p:nvCxnSpPr>
-        <p:spPr>
-          <a:xfrm flipV="1">
-            <a:off x="3139408" y="3119311"/>
-            <a:ext cx="656317" cy="316588"/>
-          </a:xfrm>
-          <a:prstGeom prst="straightConnector1">
-            <a:avLst/>
-          </a:prstGeom>
-          <a:ln w="38100">
-            <a:solidFill>
-              <a:schemeClr val="tx1"/>
-            </a:solidFill>
-            <a:headEnd type="none" w="med" len="med"/>
-            <a:tailEnd type="triangle" w="med" len="med"/>
-          </a:ln>
-        </p:spPr>
-        <p:style>
-          <a:lnRef idx="3">
-            <a:schemeClr val="dk1"/>
-          </a:lnRef>
-          <a:fillRef idx="0">
-            <a:schemeClr val="dk1"/>
-          </a:fillRef>
-          <a:effectRef idx="2">
-            <a:schemeClr val="dk1"/>
-          </a:effectRef>
-          <a:fontRef idx="minor">
-            <a:schemeClr val="tx1"/>
-          </a:fontRef>
-        </p:style>
-      </p:cxnSp>
-      <p:cxnSp>
-        <p:nvCxnSpPr>
-          <p:cNvPr id="51" name="Connecteur droit avec flèche 50"/>
-          <p:cNvCxnSpPr>
-            <a:stCxn id="17" idx="3"/>
-            <a:endCxn id="18" idx="1"/>
-          </p:cNvCxnSpPr>
-          <p:nvPr/>
-        </p:nvCxnSpPr>
-        <p:spPr>
-          <a:xfrm flipV="1">
-            <a:off x="3171797" y="4014203"/>
-            <a:ext cx="771791" cy="685419"/>
-          </a:xfrm>
-          <a:prstGeom prst="straightConnector1">
-            <a:avLst/>
-          </a:prstGeom>
-          <a:ln w="38100">
-            <a:solidFill>
-              <a:schemeClr val="tx1"/>
-            </a:solidFill>
-            <a:headEnd type="none" w="med" len="med"/>
-            <a:tailEnd type="triangle" w="med" len="med"/>
-          </a:ln>
-        </p:spPr>
-        <p:style>
-          <a:lnRef idx="3">
-            <a:schemeClr val="dk1"/>
-          </a:lnRef>
-          <a:fillRef idx="0">
-            <a:schemeClr val="dk1"/>
-          </a:fillRef>
-          <a:effectRef idx="2">
-            <a:schemeClr val="dk1"/>
-          </a:effectRef>
-          <a:fontRef idx="minor">
-            <a:schemeClr val="tx1"/>
-          </a:fontRef>
-        </p:style>
-      </p:cxnSp>
-      <p:cxnSp>
-        <p:nvCxnSpPr>
-          <p:cNvPr id="54" name="Connecteur droit avec flèche 53"/>
-          <p:cNvCxnSpPr>
-            <a:stCxn id="9" idx="3"/>
-            <a:endCxn id="10" idx="1"/>
-          </p:cNvCxnSpPr>
-          <p:nvPr/>
-        </p:nvCxnSpPr>
-        <p:spPr>
-          <a:xfrm flipV="1">
-            <a:off x="3140956" y="4538986"/>
-            <a:ext cx="848896" cy="1456945"/>
-          </a:xfrm>
-          <a:prstGeom prst="straightConnector1">
-            <a:avLst/>
-          </a:prstGeom>
-          <a:ln w="38100">
-            <a:solidFill>
-              <a:schemeClr val="tx1"/>
-            </a:solidFill>
-            <a:headEnd type="none" w="med" len="med"/>
-            <a:tailEnd type="triangle" w="med" len="med"/>
-          </a:ln>
-        </p:spPr>
-        <p:style>
-          <a:lnRef idx="3">
-            <a:schemeClr val="dk1"/>
-          </a:lnRef>
-          <a:fillRef idx="0">
-            <a:schemeClr val="dk1"/>
-          </a:fillRef>
-          <a:effectRef idx="2">
-            <a:schemeClr val="dk1"/>
-          </a:effectRef>
-          <a:fontRef idx="minor">
-            <a:schemeClr val="tx1"/>
-          </a:fontRef>
-        </p:style>
-      </p:cxnSp>
-      <p:sp>
-        <p:nvSpPr>
-          <p:cNvPr id="181" name="Rectangle 180"/>
-          <p:cNvSpPr/>
-          <p:nvPr/>
-        </p:nvSpPr>
-        <p:spPr>
-          <a:xfrm>
-            <a:off x="3807706" y="5542541"/>
-            <a:ext cx="914400" cy="182880"/>
-          </a:xfrm>
-          <a:prstGeom prst="rect">
-            <a:avLst/>
-          </a:prstGeom>
-        </p:spPr>
-        <p:style>
-          <a:lnRef idx="2">
-            <a:schemeClr val="accent1"/>
-          </a:lnRef>
-          <a:fillRef idx="1">
-            <a:schemeClr val="lt1"/>
-          </a:fillRef>
-          <a:effectRef idx="0">
-            <a:schemeClr val="accent1"/>
-          </a:effectRef>
-          <a:fontRef idx="minor">
-            <a:schemeClr val="dk1"/>
-          </a:fontRef>
-        </p:style>
-        <p:txBody>
-          <a:bodyPr rtlCol="0" anchor="ctr"/>
-          <a:lstStyle/>
-          <a:p>
-            <a:r>
-              <a:rPr lang="en-US" sz="800" dirty="0" smtClean="0"/>
-              <a:t>RAYLIB HEADER</a:t>
-            </a:r>
-          </a:p>
-        </p:txBody>
-      </p:sp>
-      <p:pic>
-        <p:nvPicPr>
-          <p:cNvPr id="184" name="Picture 8"/>
-          <p:cNvPicPr>
-            <a:picLocks noChangeAspect="1" noChangeArrowheads="1"/>
-          </p:cNvPicPr>
-          <p:nvPr/>
-        </p:nvPicPr>
-        <p:blipFill>
-          <a:blip r:embed="rId8" cstate="print"/>
-          <a:srcRect/>
-          <a:stretch>
-            <a:fillRect/>
-          </a:stretch>
-        </p:blipFill>
-        <p:spPr bwMode="auto">
-          <a:xfrm>
-            <a:off x="4049669" y="5097974"/>
-            <a:ext cx="395707" cy="404126"/>
-          </a:xfrm>
-          <a:prstGeom prst="rect">
-            <a:avLst/>
-          </a:prstGeom>
-          <a:noFill/>
-          <a:ln w="9525">
-            <a:noFill/>
-            <a:miter lim="800000"/>
-            <a:headEnd/>
-            <a:tailEnd/>
-          </a:ln>
-          <a:effectLst/>
-        </p:spPr>
-      </p:pic>
-      <p:sp>
-        <p:nvSpPr>
-          <p:cNvPr id="191" name="Rectangle 190"/>
-          <p:cNvSpPr/>
-          <p:nvPr/>
-        </p:nvSpPr>
-        <p:spPr>
-          <a:xfrm>
-            <a:off x="3807706" y="5761616"/>
-            <a:ext cx="914400" cy="182880"/>
-          </a:xfrm>
-          <a:prstGeom prst="rect">
-            <a:avLst/>
-          </a:prstGeom>
-        </p:spPr>
-        <p:style>
-          <a:lnRef idx="2">
-            <a:schemeClr val="accent1"/>
-          </a:lnRef>
-          <a:fillRef idx="1">
-            <a:schemeClr val="lt1"/>
-          </a:fillRef>
-          <a:effectRef idx="0">
-            <a:schemeClr val="accent1"/>
-          </a:effectRef>
-          <a:fontRef idx="minor">
-            <a:schemeClr val="dk1"/>
-          </a:fontRef>
-        </p:style>
-        <p:txBody>
-          <a:bodyPr rtlCol="0" anchor="ctr"/>
-          <a:lstStyle/>
-          <a:p>
-            <a:r>
-              <a:rPr lang="en-US" sz="800" dirty="0" smtClean="0"/>
-              <a:t>RAYLIB DLL</a:t>
-            </a:r>
-          </a:p>
-        </p:txBody>
-      </p:sp>
-      <p:cxnSp>
-        <p:nvCxnSpPr>
-          <p:cNvPr id="216" name="Connecteur droit avec flèche 215"/>
-          <p:cNvCxnSpPr>
-            <a:stCxn id="211" idx="0"/>
-            <a:endCxn id="35" idx="3"/>
-          </p:cNvCxnSpPr>
-          <p:nvPr/>
-        </p:nvCxnSpPr>
-        <p:spPr>
-          <a:xfrm flipV="1">
-            <a:off x="1762126" y="3512795"/>
-            <a:ext cx="180974" cy="1930"/>
-          </a:xfrm>
-          <a:prstGeom prst="straightConnector1">
-            <a:avLst/>
-          </a:prstGeom>
-          <a:ln w="38100">
-            <a:solidFill>
-              <a:schemeClr val="tx1"/>
-            </a:solidFill>
-            <a:headEnd type="none" w="med" len="med"/>
-            <a:tailEnd type="triangle" w="med" len="med"/>
-          </a:ln>
-        </p:spPr>
-        <p:style>
-          <a:lnRef idx="3">
-            <a:schemeClr val="dk1"/>
-          </a:lnRef>
-          <a:fillRef idx="0">
-            <a:schemeClr val="dk1"/>
-          </a:fillRef>
-          <a:effectRef idx="2">
-            <a:schemeClr val="dk1"/>
-          </a:effectRef>
-          <a:fontRef idx="minor">
-            <a:schemeClr val="tx1"/>
-          </a:fontRef>
-        </p:style>
-      </p:cxnSp>
-      <p:sp>
-        <p:nvSpPr>
-          <p:cNvPr id="224" name="Rectangle 223"/>
-          <p:cNvSpPr/>
-          <p:nvPr/>
-        </p:nvSpPr>
-        <p:spPr>
-          <a:xfrm>
-            <a:off x="2226556" y="6152141"/>
-            <a:ext cx="914400" cy="182880"/>
-          </a:xfrm>
-          <a:prstGeom prst="rect">
-            <a:avLst/>
-          </a:prstGeom>
-        </p:spPr>
-        <p:style>
-          <a:lnRef idx="2">
-            <a:schemeClr val="accent1"/>
-          </a:lnRef>
-          <a:fillRef idx="1">
-            <a:schemeClr val="lt1"/>
-          </a:fillRef>
-          <a:effectRef idx="0">
-            <a:schemeClr val="accent1"/>
-          </a:effectRef>
-          <a:fontRef idx="minor">
-            <a:schemeClr val="dk1"/>
-          </a:fontRef>
-        </p:style>
-        <p:txBody>
-          <a:bodyPr rtlCol="0" anchor="ctr"/>
-          <a:lstStyle/>
-          <a:p>
-            <a:r>
-              <a:rPr lang="en-US" sz="800" dirty="0" smtClean="0"/>
-              <a:t>ASSETS</a:t>
-            </a:r>
-            <a:endParaRPr lang="en-US" sz="800" dirty="0"/>
-          </a:p>
-        </p:txBody>
-      </p:sp>
-      <p:sp>
-        <p:nvSpPr>
-          <p:cNvPr id="225" name="Rectangle 224"/>
-          <p:cNvSpPr/>
-          <p:nvPr/>
-        </p:nvSpPr>
-        <p:spPr>
-          <a:xfrm>
-            <a:off x="2255131" y="4847216"/>
-            <a:ext cx="914400" cy="182880"/>
-          </a:xfrm>
-          <a:prstGeom prst="rect">
-            <a:avLst/>
-          </a:prstGeom>
-        </p:spPr>
-        <p:style>
-          <a:lnRef idx="2">
-            <a:schemeClr val="accent1"/>
-          </a:lnRef>
-          <a:fillRef idx="1">
-            <a:schemeClr val="lt1"/>
-          </a:fillRef>
-          <a:effectRef idx="0">
-            <a:schemeClr val="accent1"/>
-          </a:effectRef>
-          <a:fontRef idx="minor">
-            <a:schemeClr val="dk1"/>
-          </a:fontRef>
-        </p:style>
-        <p:txBody>
-          <a:bodyPr rtlCol="0" anchor="ctr"/>
-          <a:lstStyle/>
-          <a:p>
-            <a:r>
-              <a:rPr lang="en-US" sz="800" dirty="0" smtClean="0"/>
-              <a:t>ASSETS</a:t>
-            </a:r>
-            <a:endParaRPr lang="en-US" sz="800" dirty="0"/>
-          </a:p>
-        </p:txBody>
-      </p:sp>
-      <p:sp>
-        <p:nvSpPr>
-          <p:cNvPr id="226" name="Rectangle 225"/>
-          <p:cNvSpPr/>
-          <p:nvPr/>
-        </p:nvSpPr>
-        <p:spPr>
-          <a:xfrm>
-            <a:off x="2226556" y="3570866"/>
-            <a:ext cx="914400" cy="182880"/>
-          </a:xfrm>
-          <a:prstGeom prst="rect">
-            <a:avLst/>
-          </a:prstGeom>
-        </p:spPr>
-        <p:style>
-          <a:lnRef idx="2">
-            <a:schemeClr val="accent1"/>
-          </a:lnRef>
-          <a:fillRef idx="1">
-            <a:schemeClr val="lt1"/>
-          </a:fillRef>
-          <a:effectRef idx="0">
-            <a:schemeClr val="accent1"/>
-          </a:effectRef>
-          <a:fontRef idx="minor">
-            <a:schemeClr val="dk1"/>
-          </a:fontRef>
-        </p:style>
-        <p:txBody>
-          <a:bodyPr rtlCol="0" anchor="ctr"/>
-          <a:lstStyle/>
-          <a:p>
-            <a:r>
-              <a:rPr lang="en-US" sz="800" dirty="0" smtClean="0"/>
-              <a:t>ASSETS</a:t>
-            </a:r>
-            <a:endParaRPr lang="en-US" sz="800" dirty="0"/>
-          </a:p>
-        </p:txBody>
-      </p:sp>
-      <p:sp>
-        <p:nvSpPr>
-          <p:cNvPr id="227" name="Rectangle 226"/>
-          <p:cNvSpPr/>
-          <p:nvPr/>
-        </p:nvSpPr>
-        <p:spPr>
-          <a:xfrm>
-            <a:off x="2398006" y="2361191"/>
-            <a:ext cx="914400" cy="182880"/>
-          </a:xfrm>
-          <a:prstGeom prst="rect">
-            <a:avLst/>
-          </a:prstGeom>
-        </p:spPr>
-        <p:style>
-          <a:lnRef idx="2">
-            <a:schemeClr val="accent1"/>
-          </a:lnRef>
-          <a:fillRef idx="1">
-            <a:schemeClr val="lt1"/>
-          </a:fillRef>
-          <a:effectRef idx="0">
-            <a:schemeClr val="accent1"/>
-          </a:effectRef>
-          <a:fontRef idx="minor">
-            <a:schemeClr val="dk1"/>
-          </a:fontRef>
-        </p:style>
-        <p:txBody>
-          <a:bodyPr rtlCol="0" anchor="ctr"/>
-          <a:lstStyle/>
-          <a:p>
-            <a:r>
-              <a:rPr lang="en-US" sz="800" dirty="0" smtClean="0"/>
-              <a:t>ASSETS</a:t>
-            </a:r>
-            <a:endParaRPr lang="en-US" sz="800" dirty="0"/>
-          </a:p>
-        </p:txBody>
-      </p:sp>
-      <p:sp>
-        <p:nvSpPr>
-          <p:cNvPr id="228" name="Rectangle 227"/>
-          <p:cNvSpPr/>
-          <p:nvPr/>
-        </p:nvSpPr>
-        <p:spPr>
-          <a:xfrm>
-            <a:off x="2674231" y="1151516"/>
-            <a:ext cx="914400" cy="182880"/>
-          </a:xfrm>
-          <a:prstGeom prst="rect">
-            <a:avLst/>
-          </a:prstGeom>
-        </p:spPr>
-        <p:style>
-          <a:lnRef idx="2">
-            <a:schemeClr val="accent1"/>
-          </a:lnRef>
-          <a:fillRef idx="1">
-            <a:schemeClr val="lt1"/>
-          </a:fillRef>
-          <a:effectRef idx="0">
-            <a:schemeClr val="accent1"/>
-          </a:effectRef>
-          <a:fontRef idx="minor">
-            <a:schemeClr val="dk1"/>
-          </a:fontRef>
-        </p:style>
-        <p:txBody>
-          <a:bodyPr rtlCol="0" anchor="ctr"/>
-          <a:lstStyle/>
-          <a:p>
-            <a:r>
-              <a:rPr lang="en-US" sz="800" dirty="0" smtClean="0"/>
-              <a:t>ASSETS</a:t>
-            </a:r>
-            <a:endParaRPr lang="en-US" sz="800" dirty="0"/>
-          </a:p>
-        </p:txBody>
-      </p:sp>
-      <p:cxnSp>
-        <p:nvCxnSpPr>
-          <p:cNvPr id="235" name="Connecteur droit avec flèche 234"/>
-          <p:cNvCxnSpPr>
-            <a:stCxn id="212" idx="0"/>
-            <a:endCxn id="34" idx="3"/>
-          </p:cNvCxnSpPr>
-          <p:nvPr/>
-        </p:nvCxnSpPr>
-        <p:spPr>
-          <a:xfrm flipV="1">
-            <a:off x="1800226" y="2274545"/>
-            <a:ext cx="304799" cy="1930"/>
-          </a:xfrm>
-          <a:prstGeom prst="straightConnector1">
-            <a:avLst/>
-          </a:prstGeom>
-          <a:ln w="38100">
-            <a:solidFill>
-              <a:schemeClr val="tx1"/>
-            </a:solidFill>
-            <a:headEnd type="none" w="med" len="med"/>
-            <a:tailEnd type="triangle" w="med" len="med"/>
-          </a:ln>
-        </p:spPr>
-        <p:style>
-          <a:lnRef idx="3">
-            <a:schemeClr val="dk1"/>
-          </a:lnRef>
-          <a:fillRef idx="0">
-            <a:schemeClr val="dk1"/>
-          </a:fillRef>
-          <a:effectRef idx="2">
-            <a:schemeClr val="dk1"/>
-          </a:effectRef>
-          <a:fontRef idx="minor">
-            <a:schemeClr val="tx1"/>
-          </a:fontRef>
-        </p:style>
-      </p:cxnSp>
-      <p:cxnSp>
-        <p:nvCxnSpPr>
-          <p:cNvPr id="238" name="Connecteur droit avec flèche 237"/>
-          <p:cNvCxnSpPr>
-            <a:stCxn id="213" idx="0"/>
-            <a:endCxn id="32" idx="3"/>
-          </p:cNvCxnSpPr>
-          <p:nvPr/>
-        </p:nvCxnSpPr>
-        <p:spPr>
-          <a:xfrm flipV="1">
-            <a:off x="1981201" y="1055345"/>
-            <a:ext cx="419099" cy="144805"/>
-          </a:xfrm>
-          <a:prstGeom prst="straightConnector1">
-            <a:avLst/>
-          </a:prstGeom>
-          <a:ln w="38100">
-            <a:solidFill>
-              <a:schemeClr val="tx1"/>
-            </a:solidFill>
-            <a:headEnd type="none" w="med" len="med"/>
-            <a:tailEnd type="triangle" w="med" len="med"/>
-          </a:ln>
-        </p:spPr>
-        <p:style>
-          <a:lnRef idx="3">
-            <a:schemeClr val="dk1"/>
-          </a:lnRef>
-          <a:fillRef idx="0">
-            <a:schemeClr val="dk1"/>
-          </a:fillRef>
-          <a:effectRef idx="2">
-            <a:schemeClr val="dk1"/>
-          </a:effectRef>
-          <a:fontRef idx="minor">
-            <a:schemeClr val="tx1"/>
-          </a:fontRef>
-        </p:style>
-      </p:cxnSp>
-      <p:cxnSp>
-        <p:nvCxnSpPr>
-          <p:cNvPr id="241" name="Connecteur droit avec flèche 240"/>
-          <p:cNvCxnSpPr>
-            <a:stCxn id="210" idx="0"/>
-            <a:endCxn id="36" idx="3"/>
-          </p:cNvCxnSpPr>
-          <p:nvPr/>
-        </p:nvCxnSpPr>
-        <p:spPr>
-          <a:xfrm>
-            <a:off x="1800226" y="4733925"/>
-            <a:ext cx="180974" cy="26645"/>
-          </a:xfrm>
-          <a:prstGeom prst="straightConnector1">
-            <a:avLst/>
-          </a:prstGeom>
-          <a:ln w="38100">
-            <a:solidFill>
-              <a:schemeClr val="tx1"/>
-            </a:solidFill>
-            <a:headEnd type="none" w="med" len="med"/>
-            <a:tailEnd type="triangle" w="med" len="med"/>
-          </a:ln>
-        </p:spPr>
-        <p:style>
-          <a:lnRef idx="3">
-            <a:schemeClr val="dk1"/>
-          </a:lnRef>
-          <a:fillRef idx="0">
-            <a:schemeClr val="dk1"/>
-          </a:fillRef>
-          <a:effectRef idx="2">
-            <a:schemeClr val="dk1"/>
-          </a:effectRef>
-          <a:fontRef idx="minor">
-            <a:schemeClr val="tx1"/>
-          </a:fontRef>
-        </p:style>
-      </p:cxnSp>
-      <p:cxnSp>
-        <p:nvCxnSpPr>
-          <p:cNvPr id="245" name="Connecteur droit avec flèche 244"/>
-          <p:cNvCxnSpPr>
-            <a:stCxn id="9" idx="3"/>
-            <a:endCxn id="181" idx="1"/>
-          </p:cNvCxnSpPr>
-          <p:nvPr/>
-        </p:nvCxnSpPr>
-        <p:spPr>
-          <a:xfrm flipV="1">
-            <a:off x="3140956" y="5633981"/>
-            <a:ext cx="666750" cy="361950"/>
-          </a:xfrm>
-          <a:prstGeom prst="straightConnector1">
-            <a:avLst/>
-          </a:prstGeom>
-          <a:ln w="38100">
-            <a:solidFill>
-              <a:schemeClr val="tx1"/>
-            </a:solidFill>
-            <a:headEnd type="none" w="med" len="med"/>
-            <a:tailEnd type="triangle" w="med" len="med"/>
-          </a:ln>
-        </p:spPr>
-        <p:style>
-          <a:lnRef idx="3">
-            <a:schemeClr val="dk1"/>
-          </a:lnRef>
-          <a:fillRef idx="0">
-            <a:schemeClr val="dk1"/>
-          </a:fillRef>
-          <a:effectRef idx="2">
-            <a:schemeClr val="dk1"/>
-          </a:effectRef>
-          <a:fontRef idx="minor">
-            <a:schemeClr val="tx1"/>
-          </a:fontRef>
-        </p:style>
-      </p:cxnSp>
-      <p:cxnSp>
-        <p:nvCxnSpPr>
-          <p:cNvPr id="322" name="Connecteur droit avec flèche 321"/>
-          <p:cNvCxnSpPr>
-            <a:stCxn id="1032" idx="2"/>
-            <a:endCxn id="213" idx="3"/>
-          </p:cNvCxnSpPr>
-          <p:nvPr/>
-        </p:nvCxnSpPr>
-        <p:spPr>
-          <a:xfrm rot="5400000" flipH="1" flipV="1">
-            <a:off x="-183356" y="1769269"/>
-            <a:ext cx="1905000" cy="766762"/>
-          </a:xfrm>
-          <a:prstGeom prst="straightConnector1">
-            <a:avLst/>
-          </a:prstGeom>
-          <a:ln w="38100">
-            <a:solidFill>
-              <a:schemeClr val="tx1"/>
-            </a:solidFill>
-            <a:headEnd type="none" w="med" len="med"/>
-            <a:tailEnd type="triangle" w="med" len="med"/>
-          </a:ln>
-        </p:spPr>
-        <p:style>
-          <a:lnRef idx="3">
-            <a:schemeClr val="dk1"/>
-          </a:lnRef>
-          <a:fillRef idx="0">
-            <a:schemeClr val="dk1"/>
-          </a:fillRef>
-          <a:effectRef idx="2">
-            <a:schemeClr val="dk1"/>
-          </a:effectRef>
-          <a:fontRef idx="minor">
-            <a:schemeClr val="tx1"/>
-          </a:fontRef>
-        </p:style>
-      </p:cxnSp>
-      <p:cxnSp>
-        <p:nvCxnSpPr>
-          <p:cNvPr id="325" name="Connecteur droit avec flèche 324"/>
-          <p:cNvCxnSpPr>
-            <a:stCxn id="1032" idx="2"/>
-            <a:endCxn id="212" idx="3"/>
-          </p:cNvCxnSpPr>
-          <p:nvPr/>
-        </p:nvCxnSpPr>
-        <p:spPr>
-          <a:xfrm rot="5400000" flipH="1" flipV="1">
-            <a:off x="264318" y="2397919"/>
-            <a:ext cx="828675" cy="585787"/>
-          </a:xfrm>
-          <a:prstGeom prst="straightConnector1">
-            <a:avLst/>
-          </a:prstGeom>
-          <a:ln w="38100">
-            <a:solidFill>
-              <a:schemeClr val="tx1"/>
-            </a:solidFill>
-            <a:headEnd type="none" w="med" len="med"/>
-            <a:tailEnd type="triangle" w="med" len="med"/>
-          </a:ln>
-        </p:spPr>
-        <p:style>
-          <a:lnRef idx="3">
-            <a:schemeClr val="dk1"/>
-          </a:lnRef>
-          <a:fillRef idx="0">
-            <a:schemeClr val="dk1"/>
-          </a:fillRef>
-          <a:effectRef idx="2">
-            <a:schemeClr val="dk1"/>
-          </a:effectRef>
-          <a:fontRef idx="minor">
-            <a:schemeClr val="tx1"/>
-          </a:fontRef>
-        </p:style>
-      </p:cxnSp>
-      <p:cxnSp>
-        <p:nvCxnSpPr>
-          <p:cNvPr id="328" name="Connecteur droit avec flèche 327"/>
-          <p:cNvCxnSpPr>
-            <a:stCxn id="1032" idx="2"/>
-            <a:endCxn id="211" idx="3"/>
-          </p:cNvCxnSpPr>
-          <p:nvPr/>
-        </p:nvCxnSpPr>
-        <p:spPr>
-          <a:xfrm rot="16200000" flipH="1">
-            <a:off x="454819" y="3036093"/>
-            <a:ext cx="409575" cy="547687"/>
-          </a:xfrm>
-          <a:prstGeom prst="straightConnector1">
-            <a:avLst/>
-          </a:prstGeom>
-          <a:ln w="38100">
-            <a:solidFill>
-              <a:schemeClr val="tx1"/>
-            </a:solidFill>
-            <a:headEnd type="none" w="med" len="med"/>
-            <a:tailEnd type="triangle" w="med" len="med"/>
-          </a:ln>
-        </p:spPr>
-        <p:style>
-          <a:lnRef idx="3">
-            <a:schemeClr val="dk1"/>
-          </a:lnRef>
-          <a:fillRef idx="0">
-            <a:schemeClr val="dk1"/>
-          </a:fillRef>
-          <a:effectRef idx="2">
-            <a:schemeClr val="dk1"/>
-          </a:effectRef>
-          <a:fontRef idx="minor">
-            <a:schemeClr val="tx1"/>
-          </a:fontRef>
-        </p:style>
-      </p:cxnSp>
-      <p:cxnSp>
-        <p:nvCxnSpPr>
-          <p:cNvPr id="331" name="Connecteur droit avec flèche 330"/>
-          <p:cNvCxnSpPr>
-            <a:stCxn id="1032" idx="2"/>
-            <a:endCxn id="210" idx="3"/>
-          </p:cNvCxnSpPr>
-          <p:nvPr/>
-        </p:nvCxnSpPr>
-        <p:spPr>
-          <a:xfrm rot="16200000" flipH="1">
-            <a:off x="-135731" y="3626643"/>
-            <a:ext cx="1628775" cy="585787"/>
-          </a:xfrm>
-          <a:prstGeom prst="straightConnector1">
-            <a:avLst/>
-          </a:prstGeom>
-          <a:ln w="38100">
-            <a:solidFill>
-              <a:schemeClr val="tx1"/>
-            </a:solidFill>
-            <a:headEnd type="none" w="med" len="med"/>
-            <a:tailEnd type="triangle" w="med" len="med"/>
-          </a:ln>
-        </p:spPr>
-        <p:style>
-          <a:lnRef idx="3">
-            <a:schemeClr val="dk1"/>
-          </a:lnRef>
-          <a:fillRef idx="0">
-            <a:schemeClr val="dk1"/>
-          </a:fillRef>
-          <a:effectRef idx="2">
-            <a:schemeClr val="dk1"/>
-          </a:effectRef>
-          <a:fontRef idx="minor">
-            <a:schemeClr val="tx1"/>
-          </a:fontRef>
-        </p:style>
-      </p:cxnSp>
-      <p:cxnSp>
-        <p:nvCxnSpPr>
-          <p:cNvPr id="334" name="Connecteur droit avec flèche 333"/>
-          <p:cNvCxnSpPr>
-            <a:stCxn id="1032" idx="2"/>
-            <a:endCxn id="257" idx="3"/>
-          </p:cNvCxnSpPr>
-          <p:nvPr/>
-        </p:nvCxnSpPr>
-        <p:spPr>
-          <a:xfrm rot="16200000" flipH="1">
-            <a:off x="-259531" y="3750444"/>
-            <a:ext cx="2914600" cy="1624012"/>
-          </a:xfrm>
-          <a:prstGeom prst="straightConnector1">
-            <a:avLst/>
-          </a:prstGeom>
-          <a:ln w="38100">
-            <a:solidFill>
-              <a:schemeClr val="tx1"/>
-            </a:solidFill>
-            <a:headEnd type="none" w="med" len="med"/>
-            <a:tailEnd type="triangle" w="med" len="med"/>
-          </a:ln>
-        </p:spPr>
-        <p:style>
-          <a:lnRef idx="3">
-            <a:schemeClr val="dk1"/>
-          </a:lnRef>
-          <a:fillRef idx="0">
-            <a:schemeClr val="dk1"/>
-          </a:fillRef>
-          <a:effectRef idx="2">
-            <a:schemeClr val="dk1"/>
-          </a:effectRef>
-          <a:fontRef idx="minor">
-            <a:schemeClr val="tx1"/>
-          </a:fontRef>
-        </p:style>
-      </p:cxnSp>
-      <p:pic>
-        <p:nvPicPr>
-          <p:cNvPr id="1032" name="Picture 8" descr="User - Avatar &amp; Emoticons Icons"/>
-          <p:cNvPicPr>
-            <a:picLocks noChangeAspect="1" noChangeArrowheads="1"/>
-          </p:cNvPicPr>
-          <p:nvPr/>
-        </p:nvPicPr>
-        <p:blipFill>
-          <a:blip r:embed="rId9" cstate="print"/>
-          <a:srcRect/>
-          <a:stretch>
-            <a:fillRect/>
-          </a:stretch>
-        </p:blipFill>
-        <p:spPr bwMode="auto">
-          <a:xfrm>
-            <a:off x="0" y="2333625"/>
+            <a:off x="0" y="2551739"/>
             <a:ext cx="771525" cy="771525"/>
           </a:xfrm>
           <a:prstGeom prst="rect">
@@ -7419,7 +6000,7 @@
           <p:nvPr/>
         </p:nvPicPr>
         <p:blipFill>
-          <a:blip r:embed="rId10" cstate="print"/>
+          <a:blip r:embed="rId5" cstate="print"/>
           <a:srcRect/>
           <a:stretch>
             <a:fillRect/>
@@ -7493,6 +6074,1387 @@
           </a:p>
         </p:txBody>
       </p:sp>
+      <p:sp>
+        <p:nvSpPr>
+          <p:cNvPr id="200" name="Rectangle 199"/>
+          <p:cNvSpPr/>
+          <p:nvPr/>
+        </p:nvSpPr>
+        <p:spPr>
+          <a:xfrm>
+            <a:off x="1276252" y="4811702"/>
+            <a:ext cx="914400" cy="182880"/>
+          </a:xfrm>
+          <a:prstGeom prst="rect">
+            <a:avLst/>
+          </a:prstGeom>
+        </p:spPr>
+        <p:style>
+          <a:lnRef idx="2">
+            <a:schemeClr val="accent1"/>
+          </a:lnRef>
+          <a:fillRef idx="1">
+            <a:schemeClr val="lt1"/>
+          </a:fillRef>
+          <a:effectRef idx="0">
+            <a:schemeClr val="accent1"/>
+          </a:effectRef>
+          <a:fontRef idx="minor">
+            <a:schemeClr val="dk1"/>
+          </a:fontRef>
+        </p:style>
+        <p:txBody>
+          <a:bodyPr rtlCol="0" anchor="ctr"/>
+          <a:lstStyle/>
+          <a:p>
+            <a:r>
+              <a:rPr lang="en-US" sz="800" dirty="0" smtClean="0"/>
+              <a:t>SRC</a:t>
+            </a:r>
+            <a:endParaRPr lang="en-US" sz="800" dirty="0"/>
+          </a:p>
+        </p:txBody>
+      </p:sp>
+      <p:sp>
+        <p:nvSpPr>
+          <p:cNvPr id="201" name="Rectangle 200"/>
+          <p:cNvSpPr/>
+          <p:nvPr/>
+        </p:nvSpPr>
+        <p:spPr>
+          <a:xfrm>
+            <a:off x="1276252" y="5050806"/>
+            <a:ext cx="914400" cy="182880"/>
+          </a:xfrm>
+          <a:prstGeom prst="rect">
+            <a:avLst/>
+          </a:prstGeom>
+          <a:solidFill>
+            <a:schemeClr val="dk1"/>
+          </a:solidFill>
+          <a:ln>
+            <a:noFill/>
+          </a:ln>
+        </p:spPr>
+        <p:style>
+          <a:lnRef idx="0">
+            <a:scrgbClr r="0" g="0" b="0"/>
+          </a:lnRef>
+          <a:fillRef idx="0">
+            <a:scrgbClr r="0" g="0" b="0"/>
+          </a:fillRef>
+          <a:effectRef idx="0">
+            <a:scrgbClr r="0" g="0" b="0"/>
+          </a:effectRef>
+          <a:fontRef idx="minor">
+            <a:schemeClr val="lt1"/>
+          </a:fontRef>
+        </p:style>
+        <p:txBody>
+          <a:bodyPr rtlCol="0" anchor="ctr"/>
+          <a:lstStyle/>
+          <a:p>
+            <a:r>
+              <a:rPr lang="en-US" sz="800" dirty="0" smtClean="0"/>
+              <a:t>ASSETS</a:t>
+            </a:r>
+            <a:endParaRPr lang="en-US" sz="800" dirty="0"/>
+          </a:p>
+        </p:txBody>
+      </p:sp>
+      <p:sp>
+        <p:nvSpPr>
+          <p:cNvPr id="206" name="Rounded Rectangle 205"/>
+          <p:cNvSpPr/>
+          <p:nvPr/>
+        </p:nvSpPr>
+        <p:spPr>
+          <a:xfrm>
+            <a:off x="2268840" y="4268310"/>
+            <a:ext cx="1128831" cy="1022697"/>
+          </a:xfrm>
+          <a:prstGeom prst="roundRect">
+            <a:avLst/>
+          </a:prstGeom>
+          <a:solidFill>
+            <a:schemeClr val="accent1"/>
+          </a:solidFill>
+          <a:ln>
+            <a:noFill/>
+          </a:ln>
+        </p:spPr>
+        <p:style>
+          <a:lnRef idx="2">
+            <a:schemeClr val="accent4">
+              <a:shade val="50000"/>
+            </a:schemeClr>
+          </a:lnRef>
+          <a:fillRef idx="1">
+            <a:schemeClr val="accent4"/>
+          </a:fillRef>
+          <a:effectRef idx="0">
+            <a:schemeClr val="accent4"/>
+          </a:effectRef>
+          <a:fontRef idx="minor">
+            <a:schemeClr val="lt1"/>
+          </a:fontRef>
+        </p:style>
+        <p:txBody>
+          <a:bodyPr rtlCol="0" anchor="t"/>
+          <a:lstStyle/>
+          <a:p>
+            <a:endParaRPr lang="en-US" dirty="0"/>
+          </a:p>
+        </p:txBody>
+      </p:sp>
+      <p:sp>
+        <p:nvSpPr>
+          <p:cNvPr id="202" name="Rectangle 201"/>
+          <p:cNvSpPr/>
+          <p:nvPr/>
+        </p:nvSpPr>
+        <p:spPr>
+          <a:xfrm>
+            <a:off x="2367900" y="4804402"/>
+            <a:ext cx="914400" cy="182880"/>
+          </a:xfrm>
+          <a:prstGeom prst="rect">
+            <a:avLst/>
+          </a:prstGeom>
+        </p:spPr>
+        <p:style>
+          <a:lnRef idx="2">
+            <a:schemeClr val="accent1"/>
+          </a:lnRef>
+          <a:fillRef idx="1">
+            <a:schemeClr val="lt1"/>
+          </a:fillRef>
+          <a:effectRef idx="0">
+            <a:schemeClr val="accent1"/>
+          </a:effectRef>
+          <a:fontRef idx="minor">
+            <a:schemeClr val="dk1"/>
+          </a:fontRef>
+        </p:style>
+        <p:txBody>
+          <a:bodyPr rtlCol="0" anchor="ctr"/>
+          <a:lstStyle/>
+          <a:p>
+            <a:r>
+              <a:rPr lang="en-US" sz="800" dirty="0" smtClean="0"/>
+              <a:t>RAYLIB HEADER</a:t>
+            </a:r>
+          </a:p>
+        </p:txBody>
+      </p:sp>
+      <p:pic>
+        <p:nvPicPr>
+          <p:cNvPr id="203" name="Picture 8"/>
+          <p:cNvPicPr>
+            <a:picLocks noChangeAspect="1" noChangeArrowheads="1"/>
+          </p:cNvPicPr>
+          <p:nvPr/>
+        </p:nvPicPr>
+        <p:blipFill>
+          <a:blip r:embed="rId6" cstate="print"/>
+          <a:srcRect/>
+          <a:stretch>
+            <a:fillRect/>
+          </a:stretch>
+        </p:blipFill>
+        <p:spPr bwMode="auto">
+          <a:xfrm>
+            <a:off x="2626955" y="4342743"/>
+            <a:ext cx="395707" cy="404126"/>
+          </a:xfrm>
+          <a:prstGeom prst="rect">
+            <a:avLst/>
+          </a:prstGeom>
+          <a:noFill/>
+          <a:ln w="9525">
+            <a:noFill/>
+            <a:miter lim="800000"/>
+            <a:headEnd/>
+            <a:tailEnd/>
+          </a:ln>
+          <a:effectLst/>
+        </p:spPr>
+      </p:pic>
+      <p:sp>
+        <p:nvSpPr>
+          <p:cNvPr id="204" name="Rectangle 203"/>
+          <p:cNvSpPr/>
+          <p:nvPr/>
+        </p:nvSpPr>
+        <p:spPr>
+          <a:xfrm>
+            <a:off x="2367900" y="5049115"/>
+            <a:ext cx="914400" cy="182880"/>
+          </a:xfrm>
+          <a:prstGeom prst="rect">
+            <a:avLst/>
+          </a:prstGeom>
+        </p:spPr>
+        <p:style>
+          <a:lnRef idx="2">
+            <a:schemeClr val="accent1"/>
+          </a:lnRef>
+          <a:fillRef idx="1">
+            <a:schemeClr val="lt1"/>
+          </a:fillRef>
+          <a:effectRef idx="0">
+            <a:schemeClr val="accent1"/>
+          </a:effectRef>
+          <a:fontRef idx="minor">
+            <a:schemeClr val="dk1"/>
+          </a:fontRef>
+        </p:style>
+        <p:txBody>
+          <a:bodyPr rtlCol="0" anchor="ctr"/>
+          <a:lstStyle/>
+          <a:p>
+            <a:r>
+              <a:rPr lang="en-US" sz="800" dirty="0" smtClean="0"/>
+              <a:t>RAYLIB DLL</a:t>
+            </a:r>
+          </a:p>
+        </p:txBody>
+      </p:sp>
+      <p:sp>
+        <p:nvSpPr>
+          <p:cNvPr id="208" name="Rounded Rectangle 207"/>
+          <p:cNvSpPr/>
+          <p:nvPr/>
+        </p:nvSpPr>
+        <p:spPr>
+          <a:xfrm>
+            <a:off x="1098628" y="410572"/>
+            <a:ext cx="2362567" cy="1188720"/>
+          </a:xfrm>
+          <a:prstGeom prst="roundRect">
+            <a:avLst/>
+          </a:prstGeom>
+          <a:ln>
+            <a:noFill/>
+          </a:ln>
+        </p:spPr>
+        <p:style>
+          <a:lnRef idx="2">
+            <a:schemeClr val="accent1">
+              <a:shade val="50000"/>
+            </a:schemeClr>
+          </a:lnRef>
+          <a:fillRef idx="1">
+            <a:schemeClr val="accent1"/>
+          </a:fillRef>
+          <a:effectRef idx="0">
+            <a:schemeClr val="accent1"/>
+          </a:effectRef>
+          <a:fontRef idx="minor">
+            <a:schemeClr val="lt1"/>
+          </a:fontRef>
+        </p:style>
+        <p:txBody>
+          <a:bodyPr rtlCol="0" anchor="t"/>
+          <a:lstStyle/>
+          <a:p>
+            <a:r>
+              <a:rPr lang="en-US" sz="1600" b="1" dirty="0"/>
+              <a:t>UNREAL </a:t>
+            </a:r>
+            <a:r>
+              <a:rPr lang="en-US" sz="1600" b="1" dirty="0" smtClean="0"/>
+              <a:t>5</a:t>
+            </a:r>
+            <a:endParaRPr lang="en-US" sz="1600" b="1" dirty="0"/>
+          </a:p>
+        </p:txBody>
+      </p:sp>
+      <p:sp>
+        <p:nvSpPr>
+          <p:cNvPr id="215" name="Rounded Rectangle 214"/>
+          <p:cNvSpPr/>
+          <p:nvPr/>
+        </p:nvSpPr>
+        <p:spPr>
+          <a:xfrm>
+            <a:off x="2248404" y="499382"/>
+            <a:ext cx="1128831" cy="1019874"/>
+          </a:xfrm>
+          <a:prstGeom prst="roundRect">
+            <a:avLst/>
+          </a:prstGeom>
+          <a:ln>
+            <a:noFill/>
+          </a:ln>
+        </p:spPr>
+        <p:style>
+          <a:lnRef idx="2">
+            <a:schemeClr val="accent4">
+              <a:shade val="50000"/>
+            </a:schemeClr>
+          </a:lnRef>
+          <a:fillRef idx="1">
+            <a:schemeClr val="accent4"/>
+          </a:fillRef>
+          <a:effectRef idx="0">
+            <a:schemeClr val="accent4"/>
+          </a:effectRef>
+          <a:fontRef idx="minor">
+            <a:schemeClr val="lt1"/>
+          </a:fontRef>
+        </p:style>
+        <p:txBody>
+          <a:bodyPr rtlCol="0" anchor="t"/>
+          <a:lstStyle/>
+          <a:p>
+            <a:r>
+              <a:rPr lang="en-US" sz="1600" b="1" dirty="0" smtClean="0"/>
+              <a:t>PROJECT</a:t>
+            </a:r>
+            <a:endParaRPr lang="en-US" sz="1600" b="1" dirty="0"/>
+          </a:p>
+        </p:txBody>
+      </p:sp>
+      <p:pic>
+        <p:nvPicPr>
+          <p:cNvPr id="189" name="Picture 2"/>
+          <p:cNvPicPr>
+            <a:picLocks noChangeAspect="1" noChangeArrowheads="1"/>
+          </p:cNvPicPr>
+          <p:nvPr/>
+        </p:nvPicPr>
+        <p:blipFill>
+          <a:blip r:embed="rId7" cstate="print"/>
+          <a:srcRect/>
+          <a:stretch>
+            <a:fillRect/>
+          </a:stretch>
+        </p:blipFill>
+        <p:spPr bwMode="auto">
+          <a:xfrm>
+            <a:off x="1449987" y="910834"/>
+            <a:ext cx="455518" cy="425371"/>
+          </a:xfrm>
+          <a:prstGeom prst="rect">
+            <a:avLst/>
+          </a:prstGeom>
+          <a:noFill/>
+          <a:ln w="9525">
+            <a:noFill/>
+            <a:miter lim="800000"/>
+            <a:headEnd/>
+            <a:tailEnd/>
+          </a:ln>
+          <a:effectLst/>
+        </p:spPr>
+      </p:pic>
+      <p:sp>
+        <p:nvSpPr>
+          <p:cNvPr id="209" name="Rectangle 208"/>
+          <p:cNvSpPr/>
+          <p:nvPr/>
+        </p:nvSpPr>
+        <p:spPr>
+          <a:xfrm>
+            <a:off x="2360966" y="1020357"/>
+            <a:ext cx="914400" cy="182880"/>
+          </a:xfrm>
+          <a:prstGeom prst="rect">
+            <a:avLst/>
+          </a:prstGeom>
+        </p:spPr>
+        <p:style>
+          <a:lnRef idx="2">
+            <a:schemeClr val="accent1"/>
+          </a:lnRef>
+          <a:fillRef idx="1">
+            <a:schemeClr val="lt1"/>
+          </a:fillRef>
+          <a:effectRef idx="0">
+            <a:schemeClr val="accent1"/>
+          </a:effectRef>
+          <a:fontRef idx="minor">
+            <a:schemeClr val="dk1"/>
+          </a:fontRef>
+        </p:style>
+        <p:txBody>
+          <a:bodyPr rtlCol="0" anchor="ctr"/>
+          <a:lstStyle/>
+          <a:p>
+            <a:r>
+              <a:rPr lang="en-US" sz="800" dirty="0"/>
+              <a:t>UNREAL5_SCRIPT</a:t>
+            </a:r>
+            <a:endParaRPr lang="en-US" sz="800" dirty="0"/>
+          </a:p>
+        </p:txBody>
+      </p:sp>
+      <p:sp>
+        <p:nvSpPr>
+          <p:cNvPr id="214" name="Rectangle 213"/>
+          <p:cNvSpPr/>
+          <p:nvPr/>
+        </p:nvSpPr>
+        <p:spPr>
+          <a:xfrm>
+            <a:off x="2360966" y="1268007"/>
+            <a:ext cx="914400" cy="182880"/>
+          </a:xfrm>
+          <a:prstGeom prst="rect">
+            <a:avLst/>
+          </a:prstGeom>
+          <a:solidFill>
+            <a:schemeClr val="dk1"/>
+          </a:solidFill>
+          <a:ln>
+            <a:noFill/>
+          </a:ln>
+        </p:spPr>
+        <p:style>
+          <a:lnRef idx="0">
+            <a:scrgbClr r="0" g="0" b="0"/>
+          </a:lnRef>
+          <a:fillRef idx="0">
+            <a:scrgbClr r="0" g="0" b="0"/>
+          </a:fillRef>
+          <a:effectRef idx="0">
+            <a:scrgbClr r="0" g="0" b="0"/>
+          </a:effectRef>
+          <a:fontRef idx="minor">
+            <a:schemeClr val="lt1"/>
+          </a:fontRef>
+        </p:style>
+        <p:txBody>
+          <a:bodyPr rtlCol="0" anchor="ctr"/>
+          <a:lstStyle/>
+          <a:p>
+            <a:r>
+              <a:rPr lang="en-US" sz="800" dirty="0" smtClean="0"/>
+              <a:t>ASSETS</a:t>
+            </a:r>
+            <a:endParaRPr lang="en-US" sz="800" dirty="0"/>
+          </a:p>
+        </p:txBody>
+      </p:sp>
+      <p:sp>
+        <p:nvSpPr>
+          <p:cNvPr id="220" name="Rounded Rectangle 219"/>
+          <p:cNvSpPr/>
+          <p:nvPr/>
+        </p:nvSpPr>
+        <p:spPr>
+          <a:xfrm>
+            <a:off x="1096043" y="1658321"/>
+            <a:ext cx="2362567" cy="1188720"/>
+          </a:xfrm>
+          <a:prstGeom prst="roundRect">
+            <a:avLst/>
+          </a:prstGeom>
+          <a:ln>
+            <a:noFill/>
+          </a:ln>
+        </p:spPr>
+        <p:style>
+          <a:lnRef idx="2">
+            <a:schemeClr val="accent1">
+              <a:shade val="50000"/>
+            </a:schemeClr>
+          </a:lnRef>
+          <a:fillRef idx="1">
+            <a:schemeClr val="accent1"/>
+          </a:fillRef>
+          <a:effectRef idx="0">
+            <a:schemeClr val="accent1"/>
+          </a:effectRef>
+          <a:fontRef idx="minor">
+            <a:schemeClr val="lt1"/>
+          </a:fontRef>
+        </p:style>
+        <p:txBody>
+          <a:bodyPr rtlCol="0" anchor="t"/>
+          <a:lstStyle/>
+          <a:p>
+            <a:r>
+              <a:rPr lang="en-US" sz="1600" b="1" dirty="0" smtClean="0"/>
+              <a:t>UNITY 6</a:t>
+            </a:r>
+            <a:endParaRPr lang="en-US" sz="1600" b="1" dirty="0"/>
+          </a:p>
+        </p:txBody>
+      </p:sp>
+      <p:sp>
+        <p:nvSpPr>
+          <p:cNvPr id="221" name="Rounded Rectangle 220"/>
+          <p:cNvSpPr/>
+          <p:nvPr/>
+        </p:nvSpPr>
+        <p:spPr>
+          <a:xfrm>
+            <a:off x="2245819" y="1747131"/>
+            <a:ext cx="1128831" cy="1019874"/>
+          </a:xfrm>
+          <a:prstGeom prst="roundRect">
+            <a:avLst/>
+          </a:prstGeom>
+          <a:ln>
+            <a:noFill/>
+          </a:ln>
+        </p:spPr>
+        <p:style>
+          <a:lnRef idx="2">
+            <a:schemeClr val="accent4">
+              <a:shade val="50000"/>
+            </a:schemeClr>
+          </a:lnRef>
+          <a:fillRef idx="1">
+            <a:schemeClr val="accent4"/>
+          </a:fillRef>
+          <a:effectRef idx="0">
+            <a:schemeClr val="accent4"/>
+          </a:effectRef>
+          <a:fontRef idx="minor">
+            <a:schemeClr val="lt1"/>
+          </a:fontRef>
+        </p:style>
+        <p:txBody>
+          <a:bodyPr rtlCol="0" anchor="t"/>
+          <a:lstStyle/>
+          <a:p>
+            <a:r>
+              <a:rPr lang="en-US" sz="1600" b="1" dirty="0" smtClean="0"/>
+              <a:t>PROJECT</a:t>
+            </a:r>
+            <a:endParaRPr lang="en-US" sz="1600" b="1" dirty="0"/>
+          </a:p>
+        </p:txBody>
+      </p:sp>
+      <p:sp>
+        <p:nvSpPr>
+          <p:cNvPr id="223" name="Rectangle 222"/>
+          <p:cNvSpPr/>
+          <p:nvPr/>
+        </p:nvSpPr>
+        <p:spPr>
+          <a:xfrm>
+            <a:off x="2358381" y="2268106"/>
+            <a:ext cx="914400" cy="182880"/>
+          </a:xfrm>
+          <a:prstGeom prst="rect">
+            <a:avLst/>
+          </a:prstGeom>
+        </p:spPr>
+        <p:style>
+          <a:lnRef idx="2">
+            <a:schemeClr val="accent1"/>
+          </a:lnRef>
+          <a:fillRef idx="1">
+            <a:schemeClr val="lt1"/>
+          </a:fillRef>
+          <a:effectRef idx="0">
+            <a:schemeClr val="accent1"/>
+          </a:effectRef>
+          <a:fontRef idx="minor">
+            <a:schemeClr val="dk1"/>
+          </a:fontRef>
+        </p:style>
+        <p:txBody>
+          <a:bodyPr rtlCol="0" anchor="ctr"/>
+          <a:lstStyle/>
+          <a:p>
+            <a:r>
+              <a:rPr lang="en-US" sz="800" dirty="0"/>
+              <a:t>UNITY6_SCRIPT</a:t>
+            </a:r>
+            <a:endParaRPr lang="en-US" sz="800" dirty="0"/>
+          </a:p>
+        </p:txBody>
+      </p:sp>
+      <p:sp>
+        <p:nvSpPr>
+          <p:cNvPr id="229" name="Rectangle 228"/>
+          <p:cNvSpPr/>
+          <p:nvPr/>
+        </p:nvSpPr>
+        <p:spPr>
+          <a:xfrm>
+            <a:off x="2358381" y="2515756"/>
+            <a:ext cx="914400" cy="182880"/>
+          </a:xfrm>
+          <a:prstGeom prst="rect">
+            <a:avLst/>
+          </a:prstGeom>
+          <a:solidFill>
+            <a:schemeClr val="dk1"/>
+          </a:solidFill>
+          <a:ln>
+            <a:noFill/>
+          </a:ln>
+        </p:spPr>
+        <p:style>
+          <a:lnRef idx="0">
+            <a:scrgbClr r="0" g="0" b="0"/>
+          </a:lnRef>
+          <a:fillRef idx="0">
+            <a:scrgbClr r="0" g="0" b="0"/>
+          </a:fillRef>
+          <a:effectRef idx="0">
+            <a:scrgbClr r="0" g="0" b="0"/>
+          </a:effectRef>
+          <a:fontRef idx="minor">
+            <a:schemeClr val="lt1"/>
+          </a:fontRef>
+        </p:style>
+        <p:txBody>
+          <a:bodyPr rtlCol="0" anchor="ctr"/>
+          <a:lstStyle/>
+          <a:p>
+            <a:r>
+              <a:rPr lang="en-US" sz="800" dirty="0" smtClean="0"/>
+              <a:t>ASSETS</a:t>
+            </a:r>
+            <a:endParaRPr lang="en-US" sz="800" dirty="0"/>
+          </a:p>
+        </p:txBody>
+      </p:sp>
+      <p:sp>
+        <p:nvSpPr>
+          <p:cNvPr id="230" name="Rounded Rectangle 229"/>
+          <p:cNvSpPr/>
+          <p:nvPr/>
+        </p:nvSpPr>
+        <p:spPr>
+          <a:xfrm>
+            <a:off x="1104231" y="2921474"/>
+            <a:ext cx="2362567" cy="1188720"/>
+          </a:xfrm>
+          <a:prstGeom prst="roundRect">
+            <a:avLst/>
+          </a:prstGeom>
+          <a:ln>
+            <a:noFill/>
+          </a:ln>
+        </p:spPr>
+        <p:style>
+          <a:lnRef idx="2">
+            <a:schemeClr val="accent1">
+              <a:shade val="50000"/>
+            </a:schemeClr>
+          </a:lnRef>
+          <a:fillRef idx="1">
+            <a:schemeClr val="accent1"/>
+          </a:fillRef>
+          <a:effectRef idx="0">
+            <a:schemeClr val="accent1"/>
+          </a:effectRef>
+          <a:fontRef idx="minor">
+            <a:schemeClr val="lt1"/>
+          </a:fontRef>
+        </p:style>
+        <p:txBody>
+          <a:bodyPr rtlCol="0" anchor="t"/>
+          <a:lstStyle/>
+          <a:p>
+            <a:r>
+              <a:rPr lang="en-US" sz="1600" b="1" dirty="0" smtClean="0"/>
+              <a:t>GODOT 4</a:t>
+            </a:r>
+            <a:endParaRPr lang="en-US" sz="1600" b="1" dirty="0"/>
+          </a:p>
+        </p:txBody>
+      </p:sp>
+      <p:sp>
+        <p:nvSpPr>
+          <p:cNvPr id="231" name="Rounded Rectangle 230"/>
+          <p:cNvSpPr/>
+          <p:nvPr/>
+        </p:nvSpPr>
+        <p:spPr>
+          <a:xfrm>
+            <a:off x="2254007" y="3010284"/>
+            <a:ext cx="1128831" cy="1019874"/>
+          </a:xfrm>
+          <a:prstGeom prst="roundRect">
+            <a:avLst/>
+          </a:prstGeom>
+          <a:ln>
+            <a:noFill/>
+          </a:ln>
+        </p:spPr>
+        <p:style>
+          <a:lnRef idx="2">
+            <a:schemeClr val="accent4">
+              <a:shade val="50000"/>
+            </a:schemeClr>
+          </a:lnRef>
+          <a:fillRef idx="1">
+            <a:schemeClr val="accent4"/>
+          </a:fillRef>
+          <a:effectRef idx="0">
+            <a:schemeClr val="accent4"/>
+          </a:effectRef>
+          <a:fontRef idx="minor">
+            <a:schemeClr val="lt1"/>
+          </a:fontRef>
+        </p:style>
+        <p:txBody>
+          <a:bodyPr rtlCol="0" anchor="t"/>
+          <a:lstStyle/>
+          <a:p>
+            <a:r>
+              <a:rPr lang="en-US" sz="1600" b="1" dirty="0" smtClean="0"/>
+              <a:t>PROJECT</a:t>
+            </a:r>
+            <a:endParaRPr lang="en-US" sz="1600" b="1" dirty="0"/>
+          </a:p>
+        </p:txBody>
+      </p:sp>
+      <p:sp>
+        <p:nvSpPr>
+          <p:cNvPr id="233" name="Rectangle 232"/>
+          <p:cNvSpPr/>
+          <p:nvPr/>
+        </p:nvSpPr>
+        <p:spPr>
+          <a:xfrm>
+            <a:off x="2366569" y="3531259"/>
+            <a:ext cx="914400" cy="182880"/>
+          </a:xfrm>
+          <a:prstGeom prst="rect">
+            <a:avLst/>
+          </a:prstGeom>
+        </p:spPr>
+        <p:style>
+          <a:lnRef idx="2">
+            <a:schemeClr val="accent1"/>
+          </a:lnRef>
+          <a:fillRef idx="1">
+            <a:schemeClr val="lt1"/>
+          </a:fillRef>
+          <a:effectRef idx="0">
+            <a:schemeClr val="accent1"/>
+          </a:effectRef>
+          <a:fontRef idx="minor">
+            <a:schemeClr val="dk1"/>
+          </a:fontRef>
+        </p:style>
+        <p:txBody>
+          <a:bodyPr rtlCol="0" anchor="ctr"/>
+          <a:lstStyle/>
+          <a:p>
+            <a:r>
+              <a:rPr lang="en-US" sz="800" dirty="0"/>
+              <a:t>GODOT4_SCRIPT</a:t>
+            </a:r>
+            <a:endParaRPr lang="en-US" sz="800" dirty="0"/>
+          </a:p>
+        </p:txBody>
+      </p:sp>
+      <p:sp>
+        <p:nvSpPr>
+          <p:cNvPr id="234" name="Rectangle 233"/>
+          <p:cNvSpPr/>
+          <p:nvPr/>
+        </p:nvSpPr>
+        <p:spPr>
+          <a:xfrm>
+            <a:off x="2366569" y="3778909"/>
+            <a:ext cx="914400" cy="182880"/>
+          </a:xfrm>
+          <a:prstGeom prst="rect">
+            <a:avLst/>
+          </a:prstGeom>
+          <a:solidFill>
+            <a:schemeClr val="dk1"/>
+          </a:solidFill>
+          <a:ln>
+            <a:noFill/>
+          </a:ln>
+        </p:spPr>
+        <p:style>
+          <a:lnRef idx="0">
+            <a:scrgbClr r="0" g="0" b="0"/>
+          </a:lnRef>
+          <a:fillRef idx="0">
+            <a:scrgbClr r="0" g="0" b="0"/>
+          </a:fillRef>
+          <a:effectRef idx="0">
+            <a:scrgbClr r="0" g="0" b="0"/>
+          </a:effectRef>
+          <a:fontRef idx="minor">
+            <a:schemeClr val="lt1"/>
+          </a:fontRef>
+        </p:style>
+        <p:txBody>
+          <a:bodyPr rtlCol="0" anchor="ctr"/>
+          <a:lstStyle/>
+          <a:p>
+            <a:r>
+              <a:rPr lang="en-US" sz="800" dirty="0" smtClean="0"/>
+              <a:t>ASSETS</a:t>
+            </a:r>
+            <a:endParaRPr lang="en-US" sz="800" dirty="0"/>
+          </a:p>
+        </p:txBody>
+      </p:sp>
+      <p:sp>
+        <p:nvSpPr>
+          <p:cNvPr id="236" name="Rounded Rectangle 235"/>
+          <p:cNvSpPr/>
+          <p:nvPr/>
+        </p:nvSpPr>
+        <p:spPr>
+          <a:xfrm>
+            <a:off x="1108373" y="5464557"/>
+            <a:ext cx="2390473" cy="1176671"/>
+          </a:xfrm>
+          <a:prstGeom prst="roundRect">
+            <a:avLst/>
+          </a:prstGeom>
+          <a:solidFill>
+            <a:srgbClr val="FFC000"/>
+          </a:solidFill>
+          <a:ln>
+            <a:noFill/>
+          </a:ln>
+        </p:spPr>
+        <p:style>
+          <a:lnRef idx="2">
+            <a:schemeClr val="accent1">
+              <a:shade val="50000"/>
+            </a:schemeClr>
+          </a:lnRef>
+          <a:fillRef idx="1">
+            <a:schemeClr val="accent1"/>
+          </a:fillRef>
+          <a:effectRef idx="0">
+            <a:schemeClr val="accent1"/>
+          </a:effectRef>
+          <a:fontRef idx="minor">
+            <a:schemeClr val="lt1"/>
+          </a:fontRef>
+        </p:style>
+        <p:txBody>
+          <a:bodyPr rtlCol="0" anchor="t"/>
+          <a:lstStyle/>
+          <a:p>
+            <a:r>
+              <a:rPr lang="en-US" sz="1600" b="1" dirty="0" smtClean="0"/>
+              <a:t>PROJECT</a:t>
+            </a:r>
+          </a:p>
+          <a:p>
+            <a:r>
+              <a:rPr lang="en-US" sz="1600" b="1" dirty="0" smtClean="0"/>
+              <a:t>(C99)</a:t>
+            </a:r>
+            <a:endParaRPr lang="en-US" sz="1600" b="1" dirty="0"/>
+          </a:p>
+        </p:txBody>
+      </p:sp>
+      <p:sp>
+        <p:nvSpPr>
+          <p:cNvPr id="237" name="Rectangle 236"/>
+          <p:cNvSpPr/>
+          <p:nvPr/>
+        </p:nvSpPr>
+        <p:spPr>
+          <a:xfrm>
+            <a:off x="1293467" y="6101295"/>
+            <a:ext cx="914400" cy="182880"/>
+          </a:xfrm>
+          <a:prstGeom prst="rect">
+            <a:avLst/>
+          </a:prstGeom>
+        </p:spPr>
+        <p:style>
+          <a:lnRef idx="2">
+            <a:schemeClr val="accent1"/>
+          </a:lnRef>
+          <a:fillRef idx="1">
+            <a:schemeClr val="lt1"/>
+          </a:fillRef>
+          <a:effectRef idx="0">
+            <a:schemeClr val="accent1"/>
+          </a:effectRef>
+          <a:fontRef idx="minor">
+            <a:schemeClr val="dk1"/>
+          </a:fontRef>
+        </p:style>
+        <p:txBody>
+          <a:bodyPr rtlCol="0" anchor="ctr"/>
+          <a:lstStyle/>
+          <a:p>
+            <a:r>
+              <a:rPr lang="en-US" sz="800" dirty="0" smtClean="0"/>
+              <a:t>SRC</a:t>
+            </a:r>
+            <a:endParaRPr lang="en-US" sz="800" dirty="0"/>
+          </a:p>
+        </p:txBody>
+      </p:sp>
+      <p:sp>
+        <p:nvSpPr>
+          <p:cNvPr id="239" name="Rectangle 238"/>
+          <p:cNvSpPr/>
+          <p:nvPr/>
+        </p:nvSpPr>
+        <p:spPr>
+          <a:xfrm>
+            <a:off x="1293467" y="6340399"/>
+            <a:ext cx="914400" cy="182880"/>
+          </a:xfrm>
+          <a:prstGeom prst="rect">
+            <a:avLst/>
+          </a:prstGeom>
+          <a:solidFill>
+            <a:schemeClr val="dk1"/>
+          </a:solidFill>
+          <a:ln>
+            <a:noFill/>
+          </a:ln>
+        </p:spPr>
+        <p:style>
+          <a:lnRef idx="0">
+            <a:scrgbClr r="0" g="0" b="0"/>
+          </a:lnRef>
+          <a:fillRef idx="0">
+            <a:scrgbClr r="0" g="0" b="0"/>
+          </a:fillRef>
+          <a:effectRef idx="0">
+            <a:scrgbClr r="0" g="0" b="0"/>
+          </a:effectRef>
+          <a:fontRef idx="minor">
+            <a:schemeClr val="lt1"/>
+          </a:fontRef>
+        </p:style>
+        <p:txBody>
+          <a:bodyPr rtlCol="0" anchor="ctr"/>
+          <a:lstStyle/>
+          <a:p>
+            <a:r>
+              <a:rPr lang="en-US" sz="800" dirty="0" smtClean="0"/>
+              <a:t>ASSETS</a:t>
+            </a:r>
+            <a:endParaRPr lang="en-US" sz="800" dirty="0"/>
+          </a:p>
+        </p:txBody>
+      </p:sp>
+      <p:sp>
+        <p:nvSpPr>
+          <p:cNvPr id="240" name="Rounded Rectangle 239"/>
+          <p:cNvSpPr/>
+          <p:nvPr/>
+        </p:nvSpPr>
+        <p:spPr>
+          <a:xfrm>
+            <a:off x="2286055" y="5557903"/>
+            <a:ext cx="1128831" cy="1022697"/>
+          </a:xfrm>
+          <a:prstGeom prst="roundRect">
+            <a:avLst/>
+          </a:prstGeom>
+          <a:solidFill>
+            <a:schemeClr val="accent1"/>
+          </a:solidFill>
+          <a:ln>
+            <a:noFill/>
+          </a:ln>
+        </p:spPr>
+        <p:style>
+          <a:lnRef idx="2">
+            <a:schemeClr val="accent4">
+              <a:shade val="50000"/>
+            </a:schemeClr>
+          </a:lnRef>
+          <a:fillRef idx="1">
+            <a:schemeClr val="accent4"/>
+          </a:fillRef>
+          <a:effectRef idx="0">
+            <a:schemeClr val="accent4"/>
+          </a:effectRef>
+          <a:fontRef idx="minor">
+            <a:schemeClr val="lt1"/>
+          </a:fontRef>
+        </p:style>
+        <p:txBody>
+          <a:bodyPr rtlCol="0" anchor="t"/>
+          <a:lstStyle/>
+          <a:p>
+            <a:endParaRPr lang="en-US" dirty="0"/>
+          </a:p>
+        </p:txBody>
+      </p:sp>
+      <p:sp>
+        <p:nvSpPr>
+          <p:cNvPr id="242" name="Rectangle 241"/>
+          <p:cNvSpPr/>
+          <p:nvPr/>
+        </p:nvSpPr>
+        <p:spPr>
+          <a:xfrm>
+            <a:off x="2385115" y="6093995"/>
+            <a:ext cx="914400" cy="182880"/>
+          </a:xfrm>
+          <a:prstGeom prst="rect">
+            <a:avLst/>
+          </a:prstGeom>
+        </p:spPr>
+        <p:style>
+          <a:lnRef idx="2">
+            <a:schemeClr val="accent1"/>
+          </a:lnRef>
+          <a:fillRef idx="1">
+            <a:schemeClr val="lt1"/>
+          </a:fillRef>
+          <a:effectRef idx="0">
+            <a:schemeClr val="accent1"/>
+          </a:effectRef>
+          <a:fontRef idx="minor">
+            <a:schemeClr val="dk1"/>
+          </a:fontRef>
+        </p:style>
+        <p:txBody>
+          <a:bodyPr rtlCol="0" anchor="ctr"/>
+          <a:lstStyle/>
+          <a:p>
+            <a:r>
+              <a:rPr lang="en-US" sz="800" dirty="0"/>
+              <a:t>SDL HEADER</a:t>
+            </a:r>
+          </a:p>
+        </p:txBody>
+      </p:sp>
+      <p:sp>
+        <p:nvSpPr>
+          <p:cNvPr id="244" name="Rectangle 243"/>
+          <p:cNvSpPr/>
+          <p:nvPr/>
+        </p:nvSpPr>
+        <p:spPr>
+          <a:xfrm>
+            <a:off x="2385115" y="6338708"/>
+            <a:ext cx="914400" cy="182880"/>
+          </a:xfrm>
+          <a:prstGeom prst="rect">
+            <a:avLst/>
+          </a:prstGeom>
+        </p:spPr>
+        <p:style>
+          <a:lnRef idx="2">
+            <a:schemeClr val="accent1"/>
+          </a:lnRef>
+          <a:fillRef idx="1">
+            <a:schemeClr val="lt1"/>
+          </a:fillRef>
+          <a:effectRef idx="0">
+            <a:schemeClr val="accent1"/>
+          </a:effectRef>
+          <a:fontRef idx="minor">
+            <a:schemeClr val="dk1"/>
+          </a:fontRef>
+        </p:style>
+        <p:txBody>
+          <a:bodyPr rtlCol="0" anchor="ctr"/>
+          <a:lstStyle/>
+          <a:p>
+            <a:r>
+              <a:rPr lang="en-US" sz="800" dirty="0"/>
+              <a:t>SDL DLL</a:t>
+            </a:r>
+          </a:p>
+        </p:txBody>
+      </p:sp>
+      <p:pic>
+        <p:nvPicPr>
+          <p:cNvPr id="7" name="Picture 6"/>
+          <p:cNvPicPr>
+            <a:picLocks noChangeAspect="1"/>
+          </p:cNvPicPr>
+          <p:nvPr/>
+        </p:nvPicPr>
+        <p:blipFill>
+          <a:blip r:embed="rId8"/>
+          <a:stretch>
+            <a:fillRect/>
+          </a:stretch>
+        </p:blipFill>
+        <p:spPr>
+          <a:xfrm>
+            <a:off x="2621491" y="5635336"/>
+            <a:ext cx="464121" cy="376005"/>
+          </a:xfrm>
+          <a:prstGeom prst="rect">
+            <a:avLst/>
+          </a:prstGeom>
+        </p:spPr>
+      </p:pic>
+      <p:pic>
+        <p:nvPicPr>
+          <p:cNvPr id="246" name="Picture 5"/>
+          <p:cNvPicPr>
+            <a:picLocks noChangeAspect="1" noChangeArrowheads="1"/>
+          </p:cNvPicPr>
+          <p:nvPr/>
+        </p:nvPicPr>
+        <p:blipFill>
+          <a:blip r:embed="rId9" cstate="print"/>
+          <a:srcRect/>
+          <a:stretch>
+            <a:fillRect/>
+          </a:stretch>
+        </p:blipFill>
+        <p:spPr bwMode="auto">
+          <a:xfrm>
+            <a:off x="1429837" y="3402257"/>
+            <a:ext cx="470329" cy="484276"/>
+          </a:xfrm>
+          <a:prstGeom prst="rect">
+            <a:avLst/>
+          </a:prstGeom>
+          <a:noFill/>
+          <a:ln w="9525">
+            <a:noFill/>
+            <a:miter lim="800000"/>
+            <a:headEnd/>
+            <a:tailEnd/>
+          </a:ln>
+          <a:effectLst/>
+        </p:spPr>
+      </p:pic>
+      <p:pic>
+        <p:nvPicPr>
+          <p:cNvPr id="247" name="Picture 3"/>
+          <p:cNvPicPr>
+            <a:picLocks noChangeAspect="1" noChangeArrowheads="1"/>
+          </p:cNvPicPr>
+          <p:nvPr/>
+        </p:nvPicPr>
+        <p:blipFill>
+          <a:blip r:embed="rId10" cstate="print"/>
+          <a:srcRect/>
+          <a:stretch>
+            <a:fillRect/>
+          </a:stretch>
+        </p:blipFill>
+        <p:spPr bwMode="auto">
+          <a:xfrm>
+            <a:off x="1462159" y="2121126"/>
+            <a:ext cx="401327" cy="454577"/>
+          </a:xfrm>
+          <a:prstGeom prst="rect">
+            <a:avLst/>
+          </a:prstGeom>
+          <a:noFill/>
+          <a:ln w="9525">
+            <a:noFill/>
+            <a:miter lim="800000"/>
+            <a:headEnd/>
+            <a:tailEnd/>
+          </a:ln>
+          <a:effectLst/>
+        </p:spPr>
+      </p:pic>
+      <p:cxnSp>
+        <p:nvCxnSpPr>
+          <p:cNvPr id="248" name="Connecteur droit avec flèche 327"/>
+          <p:cNvCxnSpPr>
+            <a:stCxn id="230" idx="3"/>
+            <a:endCxn id="13" idx="1"/>
+          </p:cNvCxnSpPr>
+          <p:nvPr/>
+        </p:nvCxnSpPr>
+        <p:spPr>
+          <a:xfrm>
+            <a:off x="3466798" y="3515834"/>
+            <a:ext cx="299945" cy="60803"/>
+          </a:xfrm>
+          <a:prstGeom prst="straightConnector1">
+            <a:avLst/>
+          </a:prstGeom>
+          <a:ln w="38100">
+            <a:solidFill>
+              <a:schemeClr val="tx1"/>
+            </a:solidFill>
+            <a:headEnd type="none" w="med" len="med"/>
+            <a:tailEnd type="triangle" w="med" len="med"/>
+          </a:ln>
+        </p:spPr>
+        <p:style>
+          <a:lnRef idx="3">
+            <a:schemeClr val="dk1"/>
+          </a:lnRef>
+          <a:fillRef idx="0">
+            <a:schemeClr val="dk1"/>
+          </a:fillRef>
+          <a:effectRef idx="2">
+            <a:schemeClr val="dk1"/>
+          </a:effectRef>
+          <a:fontRef idx="minor">
+            <a:schemeClr val="tx1"/>
+          </a:fontRef>
+        </p:style>
+      </p:cxnSp>
+      <p:cxnSp>
+        <p:nvCxnSpPr>
+          <p:cNvPr id="252" name="Connecteur droit avec flèche 327"/>
+          <p:cNvCxnSpPr>
+            <a:stCxn id="220" idx="3"/>
+            <a:endCxn id="12" idx="1"/>
+          </p:cNvCxnSpPr>
+          <p:nvPr/>
+        </p:nvCxnSpPr>
+        <p:spPr>
+          <a:xfrm>
+            <a:off x="3458610" y="2252681"/>
+            <a:ext cx="392501" cy="106581"/>
+          </a:xfrm>
+          <a:prstGeom prst="straightConnector1">
+            <a:avLst/>
+          </a:prstGeom>
+          <a:ln w="38100">
+            <a:solidFill>
+              <a:schemeClr val="tx1"/>
+            </a:solidFill>
+            <a:headEnd type="none" w="med" len="med"/>
+            <a:tailEnd type="triangle" w="med" len="med"/>
+          </a:ln>
+        </p:spPr>
+        <p:style>
+          <a:lnRef idx="3">
+            <a:schemeClr val="dk1"/>
+          </a:lnRef>
+          <a:fillRef idx="0">
+            <a:schemeClr val="dk1"/>
+          </a:fillRef>
+          <a:effectRef idx="2">
+            <a:schemeClr val="dk1"/>
+          </a:effectRef>
+          <a:fontRef idx="minor">
+            <a:schemeClr val="tx1"/>
+          </a:fontRef>
+        </p:style>
+      </p:cxnSp>
+      <p:cxnSp>
+        <p:nvCxnSpPr>
+          <p:cNvPr id="253" name="Connecteur droit avec flèche 327"/>
+          <p:cNvCxnSpPr>
+            <a:stCxn id="207" idx="3"/>
+            <a:endCxn id="10" idx="1"/>
+          </p:cNvCxnSpPr>
+          <p:nvPr/>
+        </p:nvCxnSpPr>
+        <p:spPr>
+          <a:xfrm flipV="1">
+            <a:off x="3481631" y="4442460"/>
+            <a:ext cx="506471" cy="320840"/>
+          </a:xfrm>
+          <a:prstGeom prst="straightConnector1">
+            <a:avLst/>
+          </a:prstGeom>
+          <a:ln w="38100">
+            <a:solidFill>
+              <a:schemeClr val="tx1"/>
+            </a:solidFill>
+            <a:headEnd type="none" w="med" len="med"/>
+            <a:tailEnd type="triangle" w="med" len="med"/>
+          </a:ln>
+        </p:spPr>
+        <p:style>
+          <a:lnRef idx="3">
+            <a:schemeClr val="dk1"/>
+          </a:lnRef>
+          <a:fillRef idx="0">
+            <a:schemeClr val="dk1"/>
+          </a:fillRef>
+          <a:effectRef idx="2">
+            <a:schemeClr val="dk1"/>
+          </a:effectRef>
+          <a:fontRef idx="minor">
+            <a:schemeClr val="tx1"/>
+          </a:fontRef>
+        </p:style>
+      </p:cxnSp>
+      <p:cxnSp>
+        <p:nvCxnSpPr>
+          <p:cNvPr id="254" name="Connecteur droit avec flèche 327"/>
+          <p:cNvCxnSpPr>
+            <a:stCxn id="236" idx="3"/>
+            <a:endCxn id="18" idx="1"/>
+          </p:cNvCxnSpPr>
+          <p:nvPr/>
+        </p:nvCxnSpPr>
+        <p:spPr>
+          <a:xfrm flipV="1">
+            <a:off x="3498846" y="5099099"/>
+            <a:ext cx="737024" cy="953794"/>
+          </a:xfrm>
+          <a:prstGeom prst="straightConnector1">
+            <a:avLst/>
+          </a:prstGeom>
+          <a:ln w="38100">
+            <a:solidFill>
+              <a:schemeClr val="tx1"/>
+            </a:solidFill>
+            <a:headEnd type="none" w="med" len="med"/>
+            <a:tailEnd type="triangle" w="med" len="med"/>
+          </a:ln>
+        </p:spPr>
+        <p:style>
+          <a:lnRef idx="3">
+            <a:schemeClr val="dk1"/>
+          </a:lnRef>
+          <a:fillRef idx="0">
+            <a:schemeClr val="dk1"/>
+          </a:fillRef>
+          <a:effectRef idx="2">
+            <a:schemeClr val="dk1"/>
+          </a:effectRef>
+          <a:fontRef idx="minor">
+            <a:schemeClr val="tx1"/>
+          </a:fontRef>
+        </p:style>
+      </p:cxnSp>
+      <p:cxnSp>
+        <p:nvCxnSpPr>
+          <p:cNvPr id="261" name="Connecteur droit avec flèche 327"/>
+          <p:cNvCxnSpPr>
+            <a:stCxn id="208" idx="3"/>
+            <a:endCxn id="11" idx="1"/>
+          </p:cNvCxnSpPr>
+          <p:nvPr/>
+        </p:nvCxnSpPr>
+        <p:spPr>
+          <a:xfrm>
+            <a:off x="3461195" y="1004932"/>
+            <a:ext cx="639318" cy="560556"/>
+          </a:xfrm>
+          <a:prstGeom prst="straightConnector1">
+            <a:avLst/>
+          </a:prstGeom>
+          <a:ln w="38100">
+            <a:solidFill>
+              <a:schemeClr val="tx1"/>
+            </a:solidFill>
+            <a:headEnd type="none" w="med" len="med"/>
+            <a:tailEnd type="triangle" w="med" len="med"/>
+          </a:ln>
+        </p:spPr>
+        <p:style>
+          <a:lnRef idx="3">
+            <a:schemeClr val="dk1"/>
+          </a:lnRef>
+          <a:fillRef idx="0">
+            <a:schemeClr val="dk1"/>
+          </a:fillRef>
+          <a:effectRef idx="2">
+            <a:schemeClr val="dk1"/>
+          </a:effectRef>
+          <a:fontRef idx="minor">
+            <a:schemeClr val="tx1"/>
+          </a:fontRef>
+        </p:style>
+      </p:cxnSp>
     </p:spTree>
   </p:cSld>
   <p:clrMapOvr>
@@ -9980,7 +9942,7 @@
     </p:spTree>
     <p:extLst>
       <p:ext uri="{BB962C8B-B14F-4D97-AF65-F5344CB8AC3E}">
-        <p14:creationId xmlns:p14="http://schemas.microsoft.com/office/powerpoint/2010/main" xmlns="" val="521620976"/>
+        <p14:creationId xmlns:p14="http://schemas.microsoft.com/office/powerpoint/2010/main" val="521620976"/>
       </p:ext>
     </p:extLst>
   </p:cSld>
@@ -10252,7 +10214,7 @@
   <a:extraClrSchemeLst/>
   <a:extLst>
     <a:ext uri="{05A4C25C-085E-4340-85A3-A5531E510DB2}">
-      <thm15:themeFamily xmlns:thm15="http://schemas.microsoft.com/office/thememl/2012/main" xmlns="" name="Office Theme" id="{62F939B6-93AF-4DB8-9C6B-D6C7DFDC589F}" vid="{4A3C46E8-61CC-4603-A589-7422A47A8E4A}"/>
+      <thm15:themeFamily xmlns:thm15="http://schemas.microsoft.com/office/thememl/2012/main" name="Office Theme" id="{62F939B6-93AF-4DB8-9C6B-D6C7DFDC589F}" vid="{4A3C46E8-61CC-4603-A589-7422A47A8E4A}"/>
     </a:ext>
   </a:extLst>
 </a:theme>

</xml_diff>

<commit_message>
docs: ✏️ update diagrams - replace PNG and PPTX files
</commit_message>
<xml_diff>
--- a/docs/diagrams.pptx
+++ b/docs/diagrams.pptx
@@ -3442,8 +3442,8 @@
         </p:nvSpPr>
         <p:spPr>
           <a:xfrm>
-            <a:off x="6623480" y="3063320"/>
-            <a:ext cx="1097280" cy="182880"/>
+            <a:off x="6608628" y="3131868"/>
+            <a:ext cx="1083220" cy="182880"/>
           </a:xfrm>
           <a:prstGeom prst="rect">
             <a:avLst/>
@@ -3483,8 +3483,8 @@
         </p:nvSpPr>
         <p:spPr>
           <a:xfrm>
-            <a:off x="6623480" y="3358595"/>
-            <a:ext cx="1097280" cy="182880"/>
+            <a:off x="6608628" y="3410365"/>
+            <a:ext cx="1083220" cy="182880"/>
           </a:xfrm>
           <a:prstGeom prst="rect">
             <a:avLst/>
@@ -3524,8 +3524,8 @@
         </p:nvSpPr>
         <p:spPr>
           <a:xfrm>
-            <a:off x="6575958" y="1249762"/>
-            <a:ext cx="1189428" cy="369332"/>
+            <a:off x="6324853" y="1249762"/>
+            <a:ext cx="1524841" cy="461665"/>
           </a:xfrm>
           <a:prstGeom prst="rect">
             <a:avLst/>
@@ -3538,14 +3538,14 @@
           <a:lstStyle/>
           <a:p>
             <a:r>
-              <a:rPr lang="en-US" b="1" dirty="0" smtClean="0">
+              <a:rPr lang="en-US" sz="2400" b="1" dirty="0" smtClean="0">
                 <a:solidFill>
                   <a:schemeClr val="bg1"/>
                 </a:solidFill>
               </a:rPr>
               <a:t>ADAPTERS</a:t>
             </a:r>
-            <a:endParaRPr lang="en-US" b="1" dirty="0">
+            <a:endParaRPr lang="en-US" sz="2400" b="1" dirty="0">
               <a:solidFill>
                 <a:schemeClr val="bg1"/>
               </a:solidFill>
@@ -3561,8 +3561,8 @@
         </p:nvSpPr>
         <p:spPr>
           <a:xfrm>
-            <a:off x="6735210" y="2123017"/>
-            <a:ext cx="812851" cy="369332"/>
+            <a:off x="6625365" y="2114656"/>
+            <a:ext cx="1023357" cy="461665"/>
           </a:xfrm>
           <a:prstGeom prst="rect">
             <a:avLst/>
@@ -3575,14 +3575,14 @@
           <a:lstStyle/>
           <a:p>
             <a:r>
-              <a:rPr lang="en-US" b="1" dirty="0" smtClean="0">
+              <a:rPr lang="en-US" sz="2400" b="1" dirty="0" smtClean="0">
                 <a:solidFill>
                   <a:schemeClr val="bg1"/>
                 </a:solidFill>
               </a:rPr>
               <a:t>PORTS</a:t>
             </a:r>
-            <a:endParaRPr lang="en-US" b="1" dirty="0">
+            <a:endParaRPr lang="en-US" sz="2400" b="1" dirty="0">
               <a:solidFill>
                 <a:schemeClr val="bg1"/>
               </a:solidFill>
@@ -3598,8 +3598,8 @@
         </p:nvSpPr>
         <p:spPr>
           <a:xfrm>
-            <a:off x="6801940" y="2705946"/>
-            <a:ext cx="702372" cy="369332"/>
+            <a:off x="6717373" y="2657874"/>
+            <a:ext cx="878126" cy="461665"/>
           </a:xfrm>
           <a:prstGeom prst="rect">
             <a:avLst/>
@@ -3612,14 +3612,14 @@
           <a:lstStyle/>
           <a:p>
             <a:r>
-              <a:rPr lang="en-US" b="1" dirty="0" smtClean="0">
+              <a:rPr lang="en-US" sz="2400" b="1" dirty="0" smtClean="0">
                 <a:solidFill>
                   <a:schemeClr val="bg1"/>
                 </a:solidFill>
               </a:rPr>
               <a:t>CORE</a:t>
             </a:r>
-            <a:endParaRPr lang="en-US" b="1" dirty="0">
+            <a:endParaRPr lang="en-US" sz="2400" b="1" dirty="0">
               <a:solidFill>
                 <a:schemeClr val="bg1"/>
               </a:solidFill>
@@ -3635,8 +3635,8 @@
         </p:nvSpPr>
         <p:spPr>
           <a:xfrm>
-            <a:off x="6623480" y="3663395"/>
-            <a:ext cx="1097280" cy="182880"/>
+            <a:off x="6608628" y="3681609"/>
+            <a:ext cx="1083220" cy="182880"/>
           </a:xfrm>
           <a:prstGeom prst="rect">
             <a:avLst/>
@@ -3668,86 +3668,6 @@
           </a:p>
         </p:txBody>
       </p:sp>
-      <p:cxnSp>
-        <p:nvCxnSpPr>
-          <p:cNvPr id="510" name="Connecteur droit avec flèche 509"/>
-          <p:cNvCxnSpPr>
-            <a:stCxn id="30" idx="2"/>
-            <a:endCxn id="504" idx="0"/>
-          </p:cNvCxnSpPr>
-          <p:nvPr/>
-        </p:nvCxnSpPr>
-        <p:spPr>
-          <a:xfrm>
-            <a:off x="7172120" y="3541475"/>
-            <a:ext cx="0" cy="121920"/>
-          </a:xfrm>
-          <a:prstGeom prst="straightConnector1">
-            <a:avLst/>
-          </a:prstGeom>
-          <a:ln w="38100">
-            <a:solidFill>
-              <a:schemeClr val="tx1"/>
-            </a:solidFill>
-            <a:headEnd type="none" w="med" len="med"/>
-            <a:tailEnd type="triangle" w="med" len="med"/>
-          </a:ln>
-        </p:spPr>
-        <p:style>
-          <a:lnRef idx="3">
-            <a:schemeClr val="dk1"/>
-          </a:lnRef>
-          <a:fillRef idx="0">
-            <a:schemeClr val="dk1"/>
-          </a:fillRef>
-          <a:effectRef idx="2">
-            <a:schemeClr val="dk1"/>
-          </a:effectRef>
-          <a:fontRef idx="minor">
-            <a:schemeClr val="tx1"/>
-          </a:fontRef>
-        </p:style>
-      </p:cxnSp>
-      <p:cxnSp>
-        <p:nvCxnSpPr>
-          <p:cNvPr id="513" name="Connecteur droit avec flèche 512"/>
-          <p:cNvCxnSpPr>
-            <a:stCxn id="30" idx="0"/>
-            <a:endCxn id="28" idx="2"/>
-          </p:cNvCxnSpPr>
-          <p:nvPr/>
-        </p:nvCxnSpPr>
-        <p:spPr>
-          <a:xfrm flipV="1">
-            <a:off x="7172120" y="3246200"/>
-            <a:ext cx="0" cy="112395"/>
-          </a:xfrm>
-          <a:prstGeom prst="straightConnector1">
-            <a:avLst/>
-          </a:prstGeom>
-          <a:ln w="38100">
-            <a:solidFill>
-              <a:schemeClr val="tx1"/>
-            </a:solidFill>
-            <a:headEnd type="none" w="med" len="med"/>
-            <a:tailEnd type="triangle" w="med" len="med"/>
-          </a:ln>
-        </p:spPr>
-        <p:style>
-          <a:lnRef idx="3">
-            <a:schemeClr val="dk1"/>
-          </a:lnRef>
-          <a:fillRef idx="0">
-            <a:schemeClr val="dk1"/>
-          </a:fillRef>
-          <a:effectRef idx="2">
-            <a:schemeClr val="dk1"/>
-          </a:effectRef>
-          <a:fontRef idx="minor">
-            <a:schemeClr val="tx1"/>
-          </a:fontRef>
-        </p:style>
-      </p:cxnSp>
       <p:cxnSp>
         <p:nvCxnSpPr>
           <p:cNvPr id="96" name="Connecteur droit avec flèche 95"/>
@@ -3879,7 +3799,7 @@
         <p:spPr>
           <a:xfrm>
             <a:off x="542684" y="3611916"/>
-            <a:ext cx="1111091" cy="272127"/>
+            <a:ext cx="952189" cy="329431"/>
           </a:xfrm>
           <a:prstGeom prst="straightConnector1">
             <a:avLst/>
@@ -3918,8 +3838,8 @@
         </p:nvCxnSpPr>
         <p:spPr>
           <a:xfrm flipV="1">
-            <a:off x="542684" y="747448"/>
-            <a:ext cx="1892285" cy="2864468"/>
+            <a:off x="542684" y="804752"/>
+            <a:ext cx="1733383" cy="2807164"/>
           </a:xfrm>
           <a:prstGeom prst="straightConnector1">
             <a:avLst/>
@@ -3958,8 +3878,8 @@
         </p:nvCxnSpPr>
         <p:spPr>
           <a:xfrm flipV="1">
-            <a:off x="542684" y="1375301"/>
-            <a:ext cx="1651687" cy="2236615"/>
+            <a:off x="542684" y="1432605"/>
+            <a:ext cx="1492785" cy="2179311"/>
           </a:xfrm>
           <a:prstGeom prst="straightConnector1">
             <a:avLst/>
@@ -3998,8 +3918,8 @@
         </p:nvCxnSpPr>
         <p:spPr>
           <a:xfrm flipV="1">
-            <a:off x="542684" y="2875918"/>
-            <a:ext cx="1094842" cy="735998"/>
+            <a:off x="542684" y="2933222"/>
+            <a:ext cx="935940" cy="678694"/>
           </a:xfrm>
           <a:prstGeom prst="straightConnector1">
             <a:avLst/>
@@ -4038,8 +3958,8 @@
         </p:nvCxnSpPr>
         <p:spPr>
           <a:xfrm flipV="1">
-            <a:off x="542684" y="2249039"/>
-            <a:ext cx="1278368" cy="1362877"/>
+            <a:off x="542684" y="2306343"/>
+            <a:ext cx="1119466" cy="1305573"/>
           </a:xfrm>
           <a:prstGeom prst="straightConnector1">
             <a:avLst/>
@@ -4151,8 +4071,102 @@
         </p:nvSpPr>
         <p:spPr>
           <a:xfrm>
-            <a:off x="1653775" y="3603527"/>
-            <a:ext cx="1600200" cy="561032"/>
+            <a:off x="1494873" y="3660831"/>
+            <a:ext cx="2286000" cy="561032"/>
+          </a:xfrm>
+          <a:prstGeom prst="roundRect">
+            <a:avLst/>
+          </a:prstGeom>
+          <a:solidFill>
+            <a:schemeClr val="accent3"/>
+          </a:solidFill>
+          <a:ln>
+            <a:noFill/>
+          </a:ln>
+        </p:spPr>
+        <p:style>
+          <a:lnRef idx="0">
+            <a:scrgbClr r="0" g="0" b="0"/>
+          </a:lnRef>
+          <a:fillRef idx="0">
+            <a:scrgbClr r="0" g="0" b="0"/>
+          </a:fillRef>
+          <a:effectRef idx="0">
+            <a:scrgbClr r="0" g="0" b="0"/>
+          </a:effectRef>
+          <a:fontRef idx="minor">
+            <a:schemeClr val="lt1"/>
+          </a:fontRef>
+        </p:style>
+        <p:txBody>
+          <a:bodyPr rtlCol="0" anchor="ctr"/>
+          <a:lstStyle/>
+          <a:p>
+            <a:r>
+              <a:rPr lang="en-US" sz="2400" b="1" dirty="0" smtClean="0"/>
+              <a:t>ANDROID</a:t>
+            </a:r>
+            <a:endParaRPr lang="en-US" sz="2400" b="1" dirty="0"/>
+          </a:p>
+        </p:txBody>
+      </p:sp>
+      <p:sp>
+        <p:nvSpPr>
+          <p:cNvPr id="220" name="Rounded Rectangle 219"/>
+          <p:cNvSpPr/>
+          <p:nvPr/>
+        </p:nvSpPr>
+        <p:spPr>
+          <a:xfrm>
+            <a:off x="2276067" y="524895"/>
+            <a:ext cx="2286000" cy="559714"/>
+          </a:xfrm>
+          <a:prstGeom prst="roundRect">
+            <a:avLst/>
+          </a:prstGeom>
+          <a:solidFill>
+            <a:schemeClr val="accent3"/>
+          </a:solidFill>
+          <a:ln>
+            <a:noFill/>
+          </a:ln>
+        </p:spPr>
+        <p:style>
+          <a:lnRef idx="0">
+            <a:scrgbClr r="0" g="0" b="0"/>
+          </a:lnRef>
+          <a:fillRef idx="0">
+            <a:scrgbClr r="0" g="0" b="0"/>
+          </a:fillRef>
+          <a:effectRef idx="0">
+            <a:scrgbClr r="0" g="0" b="0"/>
+          </a:effectRef>
+          <a:fontRef idx="minor">
+            <a:schemeClr val="lt1"/>
+          </a:fontRef>
+        </p:style>
+        <p:txBody>
+          <a:bodyPr rtlCol="0" anchor="ctr"/>
+          <a:lstStyle/>
+          <a:p>
+            <a:r>
+              <a:rPr lang="en-US" sz="2400" b="1" dirty="0" smtClean="0"/>
+              <a:t>UNITY 6</a:t>
+            </a:r>
+            <a:endParaRPr lang="en-US" sz="2400" b="1" dirty="0"/>
+          </a:p>
+        </p:txBody>
+      </p:sp>
+      <p:sp>
+        <p:nvSpPr>
+          <p:cNvPr id="230" name="Rounded Rectangle 229"/>
+          <p:cNvSpPr/>
+          <p:nvPr/>
+        </p:nvSpPr>
+        <p:spPr>
+          <a:xfrm>
+            <a:off x="2035469" y="1158285"/>
+            <a:ext cx="2286000" cy="548640"/>
           </a:xfrm>
           <a:prstGeom prst="roundRect">
             <a:avLst/>
@@ -4182,102 +4196,10 @@
           <a:lstStyle/>
           <a:p>
             <a:r>
-              <a:rPr lang="en-US" sz="1600" b="1" dirty="0" smtClean="0"/>
-              <a:t>ANDROID</a:t>
-            </a:r>
-            <a:endParaRPr lang="en-US" sz="1600" b="1" dirty="0"/>
-          </a:p>
-        </p:txBody>
-      </p:sp>
-      <p:sp>
-        <p:nvSpPr>
-          <p:cNvPr id="220" name="Rounded Rectangle 219"/>
-          <p:cNvSpPr/>
-          <p:nvPr/>
-        </p:nvSpPr>
-        <p:spPr>
-          <a:xfrm>
-            <a:off x="2434969" y="467591"/>
-            <a:ext cx="1592393" cy="559714"/>
-          </a:xfrm>
-          <a:prstGeom prst="roundRect">
-            <a:avLst/>
-          </a:prstGeom>
-          <a:ln>
-            <a:noFill/>
-          </a:ln>
-        </p:spPr>
-        <p:style>
-          <a:lnRef idx="2">
-            <a:schemeClr val="accent1">
-              <a:shade val="50000"/>
-            </a:schemeClr>
-          </a:lnRef>
-          <a:fillRef idx="1">
-            <a:schemeClr val="accent1"/>
-          </a:fillRef>
-          <a:effectRef idx="0">
-            <a:schemeClr val="accent1"/>
-          </a:effectRef>
-          <a:fontRef idx="minor">
-            <a:schemeClr val="lt1"/>
-          </a:fontRef>
-        </p:style>
-        <p:txBody>
-          <a:bodyPr rtlCol="0" anchor="ctr"/>
-          <a:lstStyle/>
-          <a:p>
-            <a:r>
-              <a:rPr lang="en-US" sz="1600" b="1" dirty="0" smtClean="0"/>
-              <a:t>UNITY 6</a:t>
-            </a:r>
-            <a:endParaRPr lang="en-US" sz="1600" b="1" dirty="0"/>
-          </a:p>
-        </p:txBody>
-      </p:sp>
-      <p:sp>
-        <p:nvSpPr>
-          <p:cNvPr id="230" name="Rounded Rectangle 229"/>
-          <p:cNvSpPr/>
-          <p:nvPr/>
-        </p:nvSpPr>
-        <p:spPr>
-          <a:xfrm>
-            <a:off x="2194371" y="1100981"/>
-            <a:ext cx="1600200" cy="548640"/>
-          </a:xfrm>
-          <a:prstGeom prst="roundRect">
-            <a:avLst/>
-          </a:prstGeom>
-          <a:ln>
-            <a:noFill/>
-          </a:ln>
-        </p:spPr>
-        <p:style>
-          <a:lnRef idx="2">
-            <a:schemeClr val="accent1">
-              <a:shade val="50000"/>
-            </a:schemeClr>
-          </a:lnRef>
-          <a:fillRef idx="1">
-            <a:schemeClr val="accent1"/>
-          </a:fillRef>
-          <a:effectRef idx="0">
-            <a:schemeClr val="accent1"/>
-          </a:effectRef>
-          <a:fontRef idx="minor">
-            <a:schemeClr val="lt1"/>
-          </a:fontRef>
-        </p:style>
-        <p:txBody>
-          <a:bodyPr rtlCol="0" anchor="ctr"/>
-          <a:lstStyle/>
-          <a:p>
-            <a:r>
-              <a:rPr lang="en-US" sz="1600" b="1" dirty="0" smtClean="0"/>
+              <a:rPr lang="en-US" sz="2400" b="1" dirty="0" smtClean="0"/>
               <a:t>GODOT 4</a:t>
             </a:r>
-            <a:endParaRPr lang="en-US" sz="1600" b="1" dirty="0"/>
+            <a:endParaRPr lang="en-US" sz="2400" b="1" dirty="0"/>
           </a:p>
         </p:txBody>
       </p:sp>
@@ -4289,30 +4211,28 @@
         </p:nvSpPr>
         <p:spPr>
           <a:xfrm>
-            <a:off x="1637526" y="2601598"/>
-            <a:ext cx="1600200" cy="548640"/>
+            <a:off x="1478624" y="2658902"/>
+            <a:ext cx="2286000" cy="548640"/>
           </a:xfrm>
           <a:prstGeom prst="roundRect">
             <a:avLst/>
           </a:prstGeom>
           <a:solidFill>
-            <a:srgbClr val="5B9BD5"/>
+            <a:schemeClr val="accent3"/>
           </a:solidFill>
           <a:ln>
             <a:noFill/>
           </a:ln>
         </p:spPr>
         <p:style>
-          <a:lnRef idx="2">
-            <a:schemeClr val="accent1">
-              <a:shade val="50000"/>
-            </a:schemeClr>
-          </a:lnRef>
-          <a:fillRef idx="1">
-            <a:schemeClr val="accent1"/>
+          <a:lnRef idx="0">
+            <a:scrgbClr r="0" g="0" b="0"/>
+          </a:lnRef>
+          <a:fillRef idx="0">
+            <a:scrgbClr r="0" g="0" b="0"/>
           </a:fillRef>
           <a:effectRef idx="0">
-            <a:schemeClr val="accent1"/>
+            <a:scrgbClr r="0" g="0" b="0"/>
           </a:effectRef>
           <a:fontRef idx="minor">
             <a:schemeClr val="lt1"/>
@@ -4323,10 +4243,10 @@
           <a:lstStyle/>
           <a:p>
             <a:r>
-              <a:rPr lang="en-US" sz="1600" b="1" dirty="0" smtClean="0"/>
+              <a:rPr lang="en-US" sz="2400" b="1" dirty="0" smtClean="0"/>
               <a:t>SDL 3</a:t>
             </a:r>
-            <a:endParaRPr lang="en-US" sz="1600" b="1" dirty="0"/>
+            <a:endParaRPr lang="en-US" sz="2400" b="1" dirty="0"/>
           </a:p>
         </p:txBody>
       </p:sp>
@@ -4346,7 +4266,7 @@
         </p:blipFill>
         <p:spPr>
           <a:xfrm>
-            <a:off x="2696080" y="2607178"/>
+            <a:off x="3233465" y="2664482"/>
             <a:ext cx="540131" cy="548640"/>
           </a:xfrm>
           <a:prstGeom prst="roundRect">
@@ -4382,7 +4302,7 @@
         </p:blipFill>
         <p:spPr bwMode="auto">
           <a:xfrm>
-            <a:off x="3245931" y="1109398"/>
+            <a:off x="3783316" y="1166702"/>
             <a:ext cx="532840" cy="548640"/>
           </a:xfrm>
           <a:prstGeom prst="roundRect">
@@ -4418,7 +4338,7 @@
         </p:blipFill>
         <p:spPr bwMode="auto">
           <a:xfrm>
-            <a:off x="3480444" y="473148"/>
+            <a:off x="4017829" y="530452"/>
             <a:ext cx="546918" cy="548640"/>
           </a:xfrm>
           <a:prstGeom prst="roundRect">
@@ -4448,8 +4368,8 @@
         </p:nvCxnSpPr>
         <p:spPr>
           <a:xfrm>
-            <a:off x="3794571" y="1375301"/>
-            <a:ext cx="1708722" cy="304551"/>
+            <a:off x="4321469" y="1432605"/>
+            <a:ext cx="1181824" cy="247247"/>
           </a:xfrm>
           <a:prstGeom prst="straightConnector1">
             <a:avLst/>
@@ -4488,8 +4408,8 @@
         </p:nvCxnSpPr>
         <p:spPr>
           <a:xfrm>
-            <a:off x="4027362" y="747448"/>
-            <a:ext cx="1475931" cy="932404"/>
+            <a:off x="4562067" y="804752"/>
+            <a:ext cx="941226" cy="875100"/>
           </a:xfrm>
           <a:prstGeom prst="straightConnector1">
             <a:avLst/>
@@ -4528,8 +4448,8 @@
         </p:nvCxnSpPr>
         <p:spPr>
           <a:xfrm>
-            <a:off x="3421252" y="2249039"/>
-            <a:ext cx="1436009" cy="549290"/>
+            <a:off x="3948150" y="2306343"/>
+            <a:ext cx="909111" cy="491986"/>
           </a:xfrm>
           <a:prstGeom prst="straightConnector1">
             <a:avLst/>
@@ -4568,8 +4488,8 @@
         </p:nvCxnSpPr>
         <p:spPr>
           <a:xfrm flipV="1">
-            <a:off x="3237726" y="2798329"/>
-            <a:ext cx="1619535" cy="77589"/>
+            <a:off x="3764624" y="2798329"/>
+            <a:ext cx="1092637" cy="134893"/>
           </a:xfrm>
           <a:prstGeom prst="straightConnector1">
             <a:avLst/>
@@ -4608,8 +4528,8 @@
         </p:nvCxnSpPr>
         <p:spPr>
           <a:xfrm flipV="1">
-            <a:off x="3253975" y="3813045"/>
-            <a:ext cx="1599257" cy="70998"/>
+            <a:off x="3780873" y="3813045"/>
+            <a:ext cx="1072359" cy="128302"/>
           </a:xfrm>
           <a:prstGeom prst="straightConnector1">
             <a:avLst/>
@@ -4653,7 +4573,7 @@
         </p:blipFill>
         <p:spPr>
           <a:xfrm>
-            <a:off x="2740177" y="3611916"/>
+            <a:off x="3277562" y="3669220"/>
             <a:ext cx="545723" cy="548640"/>
           </a:xfrm>
           <a:prstGeom prst="roundRect">
@@ -4820,30 +4740,28 @@
         </p:nvSpPr>
         <p:spPr>
           <a:xfrm>
-            <a:off x="2032002" y="5005381"/>
-            <a:ext cx="1600200" cy="548640"/>
+            <a:off x="1873100" y="5062685"/>
+            <a:ext cx="2286000" cy="548640"/>
           </a:xfrm>
           <a:prstGeom prst="roundRect">
             <a:avLst/>
           </a:prstGeom>
           <a:solidFill>
-            <a:srgbClr val="5B9BD5"/>
+            <a:schemeClr val="accent3"/>
           </a:solidFill>
           <a:ln>
             <a:noFill/>
           </a:ln>
         </p:spPr>
         <p:style>
-          <a:lnRef idx="2">
-            <a:schemeClr val="accent1">
-              <a:shade val="50000"/>
-            </a:schemeClr>
-          </a:lnRef>
-          <a:fillRef idx="1">
-            <a:schemeClr val="accent1"/>
+          <a:lnRef idx="0">
+            <a:scrgbClr r="0" g="0" b="0"/>
+          </a:lnRef>
+          <a:fillRef idx="0">
+            <a:scrgbClr r="0" g="0" b="0"/>
           </a:fillRef>
           <a:effectRef idx="0">
-            <a:schemeClr val="accent1"/>
+            <a:scrgbClr r="0" g="0" b="0"/>
           </a:effectRef>
           <a:fontRef idx="minor">
             <a:schemeClr val="lt1"/>
@@ -4854,10 +4772,9 @@
           <a:lstStyle/>
           <a:p>
             <a:r>
-              <a:rPr lang="en-US" sz="1600" b="1" dirty="0" smtClean="0"/>
+              <a:rPr lang="en-US" sz="2400" b="1" dirty="0" smtClean="0"/>
               <a:t>ANGULAR</a:t>
             </a:r>
-            <a:endParaRPr lang="en-US" sz="1600" b="1" dirty="0" smtClean="0"/>
           </a:p>
         </p:txBody>
       </p:sp>
@@ -4872,8 +4789,8 @@
         </p:nvCxnSpPr>
         <p:spPr>
           <a:xfrm flipV="1">
-            <a:off x="3632202" y="4990593"/>
-            <a:ext cx="1799181" cy="289108"/>
+            <a:off x="4159100" y="4990593"/>
+            <a:ext cx="1272283" cy="346412"/>
           </a:xfrm>
           <a:prstGeom prst="straightConnector1">
             <a:avLst/>
@@ -4912,8 +4829,8 @@
         </p:nvCxnSpPr>
         <p:spPr>
           <a:xfrm flipV="1">
-            <a:off x="3891784" y="4990593"/>
-            <a:ext cx="1539599" cy="937077"/>
+            <a:off x="4418682" y="4990593"/>
+            <a:ext cx="1012701" cy="994381"/>
           </a:xfrm>
           <a:prstGeom prst="straightConnector1">
             <a:avLst/>
@@ -4988,30 +4905,28 @@
         </p:nvSpPr>
         <p:spPr>
           <a:xfrm>
-            <a:off x="1821052" y="1974719"/>
-            <a:ext cx="1600200" cy="548640"/>
+            <a:off x="1662150" y="2032023"/>
+            <a:ext cx="2286000" cy="548640"/>
           </a:xfrm>
           <a:prstGeom prst="roundRect">
             <a:avLst/>
           </a:prstGeom>
           <a:solidFill>
-            <a:srgbClr val="5B9BD5"/>
+            <a:schemeClr val="accent3"/>
           </a:solidFill>
           <a:ln>
             <a:noFill/>
           </a:ln>
         </p:spPr>
         <p:style>
-          <a:lnRef idx="2">
-            <a:schemeClr val="accent1">
-              <a:shade val="50000"/>
-            </a:schemeClr>
-          </a:lnRef>
-          <a:fillRef idx="1">
-            <a:schemeClr val="accent1"/>
+          <a:lnRef idx="0">
+            <a:scrgbClr r="0" g="0" b="0"/>
+          </a:lnRef>
+          <a:fillRef idx="0">
+            <a:scrgbClr r="0" g="0" b="0"/>
           </a:fillRef>
           <a:effectRef idx="0">
-            <a:schemeClr val="accent1"/>
+            <a:scrgbClr r="0" g="0" b="0"/>
           </a:effectRef>
           <a:fontRef idx="minor">
             <a:schemeClr val="lt1"/>
@@ -5022,10 +4937,9 @@
           <a:lstStyle/>
           <a:p>
             <a:r>
-              <a:rPr lang="en-US" sz="1600" b="1" dirty="0" smtClean="0"/>
+              <a:rPr lang="en-US" sz="2400" b="1" dirty="0" smtClean="0"/>
               <a:t>RAYLIB 5</a:t>
             </a:r>
-            <a:endParaRPr lang="en-US" sz="1600" b="1" dirty="0" smtClean="0"/>
           </a:p>
         </p:txBody>
       </p:sp>
@@ -5046,7 +4960,7 @@
         </p:blipFill>
         <p:spPr bwMode="auto">
           <a:xfrm>
-            <a:off x="2879605" y="1977523"/>
+            <a:off x="3416990" y="2034827"/>
             <a:ext cx="537210" cy="548640"/>
           </a:xfrm>
           <a:prstGeom prst="roundRect">
@@ -5073,30 +4987,28 @@
         </p:nvSpPr>
         <p:spPr>
           <a:xfrm>
-            <a:off x="1849293" y="4241176"/>
-            <a:ext cx="1600200" cy="548640"/>
+            <a:off x="1690391" y="4298480"/>
+            <a:ext cx="2286000" cy="548640"/>
           </a:xfrm>
           <a:prstGeom prst="roundRect">
             <a:avLst/>
           </a:prstGeom>
           <a:solidFill>
-            <a:srgbClr val="5B9BD5"/>
+            <a:schemeClr val="accent3"/>
           </a:solidFill>
           <a:ln>
             <a:noFill/>
           </a:ln>
         </p:spPr>
         <p:style>
-          <a:lnRef idx="2">
-            <a:schemeClr val="accent1">
-              <a:shade val="50000"/>
-            </a:schemeClr>
-          </a:lnRef>
-          <a:fillRef idx="1">
-            <a:schemeClr val="accent1"/>
+          <a:lnRef idx="0">
+            <a:scrgbClr r="0" g="0" b="0"/>
+          </a:lnRef>
+          <a:fillRef idx="0">
+            <a:scrgbClr r="0" g="0" b="0"/>
           </a:fillRef>
           <a:effectRef idx="0">
-            <a:schemeClr val="accent1"/>
+            <a:scrgbClr r="0" g="0" b="0"/>
           </a:effectRef>
           <a:fontRef idx="minor">
             <a:schemeClr val="lt1"/>
@@ -5107,10 +5019,9 @@
           <a:lstStyle/>
           <a:p>
             <a:r>
-              <a:rPr lang="en-US" sz="1600" b="1" dirty="0" smtClean="0"/>
+              <a:rPr lang="en-US" sz="2400" b="1" dirty="0" smtClean="0"/>
               <a:t>IOS</a:t>
             </a:r>
-            <a:endParaRPr lang="en-US" sz="1600" b="1" dirty="0" smtClean="0"/>
           </a:p>
         </p:txBody>
       </p:sp>
@@ -5126,7 +5037,7 @@
         <p:spPr>
           <a:xfrm>
             <a:off x="542684" y="3611916"/>
-            <a:ext cx="1306609" cy="903580"/>
+            <a:ext cx="1147707" cy="960884"/>
           </a:xfrm>
           <a:prstGeom prst="straightConnector1">
             <a:avLst/>
@@ -5166,7 +5077,7 @@
         <p:spPr>
           <a:xfrm>
             <a:off x="542684" y="3611916"/>
-            <a:ext cx="1489318" cy="1667785"/>
+            <a:ext cx="1330416" cy="1725089"/>
           </a:xfrm>
           <a:prstGeom prst="straightConnector1">
             <a:avLst/>
@@ -5206,7 +5117,7 @@
         <p:spPr>
           <a:xfrm>
             <a:off x="542684" y="3611916"/>
-            <a:ext cx="1748900" cy="2315754"/>
+            <a:ext cx="1589998" cy="2373058"/>
           </a:xfrm>
           <a:prstGeom prst="straightConnector1">
             <a:avLst/>
@@ -5242,30 +5153,28 @@
         </p:nvSpPr>
         <p:spPr>
           <a:xfrm>
-            <a:off x="2291584" y="5653350"/>
-            <a:ext cx="1600200" cy="548640"/>
+            <a:off x="2132682" y="5710654"/>
+            <a:ext cx="2286000" cy="548640"/>
           </a:xfrm>
           <a:prstGeom prst="roundRect">
             <a:avLst/>
           </a:prstGeom>
           <a:solidFill>
-            <a:srgbClr val="5B9BD5"/>
+            <a:schemeClr val="accent3"/>
           </a:solidFill>
           <a:ln>
             <a:noFill/>
           </a:ln>
         </p:spPr>
         <p:style>
-          <a:lnRef idx="2">
-            <a:schemeClr val="accent1">
-              <a:shade val="50000"/>
-            </a:schemeClr>
-          </a:lnRef>
-          <a:fillRef idx="1">
-            <a:schemeClr val="accent1"/>
+          <a:lnRef idx="0">
+            <a:scrgbClr r="0" g="0" b="0"/>
+          </a:lnRef>
+          <a:fillRef idx="0">
+            <a:scrgbClr r="0" g="0" b="0"/>
           </a:fillRef>
           <a:effectRef idx="0">
-            <a:schemeClr val="accent1"/>
+            <a:scrgbClr r="0" g="0" b="0"/>
           </a:effectRef>
           <a:fontRef idx="minor">
             <a:schemeClr val="lt1"/>
@@ -5276,10 +5185,10 @@
           <a:lstStyle/>
           <a:p>
             <a:r>
-              <a:rPr lang="en-US" sz="1600" b="1" dirty="0" smtClean="0"/>
+              <a:rPr lang="en-US" sz="2400" b="1" dirty="0" smtClean="0"/>
               <a:t>REACT JS</a:t>
             </a:r>
-            <a:endParaRPr lang="en-US" sz="1600" b="1" dirty="0"/>
+            <a:endParaRPr lang="en-US" sz="2400" b="1" dirty="0"/>
           </a:p>
         </p:txBody>
       </p:sp>
@@ -5291,8 +5200,8 @@
         </p:nvSpPr>
         <p:spPr>
           <a:xfrm>
-            <a:off x="10803718" y="3565325"/>
-            <a:ext cx="1280160" cy="1188720"/>
+            <a:off x="10256569" y="3653329"/>
+            <a:ext cx="1280160" cy="1010719"/>
           </a:xfrm>
           <a:prstGeom prst="hexagon">
             <a:avLst/>
@@ -5345,7 +5254,7 @@
         </p:blipFill>
         <p:spPr bwMode="auto">
           <a:xfrm>
-            <a:off x="11271362" y="4283320"/>
+            <a:off x="10724213" y="4193324"/>
             <a:ext cx="393678" cy="393678"/>
           </a:xfrm>
           <a:prstGeom prst="rect">
@@ -5370,7 +5279,7 @@
         </p:blipFill>
         <p:spPr>
           <a:xfrm>
-            <a:off x="3271685" y="5656936"/>
+            <a:off x="3809070" y="5714240"/>
             <a:ext cx="617194" cy="545054"/>
           </a:xfrm>
           <a:prstGeom prst="roundRect">
@@ -5405,7 +5314,7 @@
         </p:blipFill>
         <p:spPr>
           <a:xfrm>
-            <a:off x="3078725" y="5006249"/>
+            <a:off x="3616110" y="5063553"/>
             <a:ext cx="560130" cy="548640"/>
           </a:xfrm>
           <a:prstGeom prst="roundRect">
@@ -5440,7 +5349,7 @@
         </p:blipFill>
         <p:spPr>
           <a:xfrm>
-            <a:off x="2911131" y="4251697"/>
+            <a:off x="3448516" y="4309001"/>
             <a:ext cx="534998" cy="538120"/>
           </a:xfrm>
           <a:prstGeom prst="roundRect">
@@ -5467,8 +5376,8 @@
         </p:nvSpPr>
         <p:spPr>
           <a:xfrm>
-            <a:off x="9747792" y="4615868"/>
-            <a:ext cx="1280160" cy="1188720"/>
+            <a:off x="9747792" y="4809254"/>
+            <a:ext cx="1280160" cy="995334"/>
           </a:xfrm>
           <a:prstGeom prst="hexagon">
             <a:avLst/>
@@ -5579,8 +5488,8 @@
         </p:nvCxnSpPr>
         <p:spPr>
           <a:xfrm>
-            <a:off x="7925446" y="3688115"/>
-            <a:ext cx="3345916" cy="792044"/>
+            <a:off x="7915857" y="3629726"/>
+            <a:ext cx="2808356" cy="760437"/>
           </a:xfrm>
           <a:prstGeom prst="straightConnector1">
             <a:avLst/>
@@ -5616,8 +5525,8 @@
         </p:nvSpPr>
         <p:spPr>
           <a:xfrm>
-            <a:off x="9308020" y="422758"/>
-            <a:ext cx="2900209" cy="2356980"/>
+            <a:off x="9308020" y="742482"/>
+            <a:ext cx="2791103" cy="1893851"/>
           </a:xfrm>
           <a:prstGeom prst="hexagon">
             <a:avLst/>
@@ -5645,10 +5554,6 @@
           <a:lstStyle/>
           <a:p>
             <a:pPr algn="ctr"/>
-            <a:r>
-              <a:rPr lang="en-US" sz="1400" b="1" dirty="0" smtClean="0"/>
-              <a:t>ASSETS</a:t>
-            </a:r>
             <a:endParaRPr lang="en-US" b="1" dirty="0"/>
           </a:p>
         </p:txBody>
@@ -5873,6 +5778,43 @@
           </a:fontRef>
         </p:style>
       </p:cxnSp>
+      <p:sp>
+        <p:nvSpPr>
+          <p:cNvPr id="104" name="Rectangle 103"/>
+          <p:cNvSpPr/>
+          <p:nvPr/>
+        </p:nvSpPr>
+        <p:spPr>
+          <a:xfrm>
+            <a:off x="10233592" y="742483"/>
+            <a:ext cx="1109727" cy="461665"/>
+          </a:xfrm>
+          <a:prstGeom prst="rect">
+            <a:avLst/>
+          </a:prstGeom>
+        </p:spPr>
+        <p:txBody>
+          <a:bodyPr wrap="none">
+            <a:spAutoFit/>
+          </a:bodyPr>
+          <a:lstStyle/>
+          <a:p>
+            <a:r>
+              <a:rPr lang="en-US" sz="2400" b="1" dirty="0" smtClean="0">
+                <a:solidFill>
+                  <a:schemeClr val="bg1"/>
+                </a:solidFill>
+              </a:rPr>
+              <a:t>ASSETS</a:t>
+            </a:r>
+            <a:endParaRPr lang="en-US" sz="2400" b="1" dirty="0">
+              <a:solidFill>
+                <a:schemeClr val="bg1"/>
+              </a:solidFill>
+            </a:endParaRPr>
+          </a:p>
+        </p:txBody>
+      </p:sp>
     </p:spTree>
   </p:cSld>
   <p:clrMapOvr>

</xml_diff>